<commit_message>
feat : SpringBoot에 Redis Cache 적용
- 적용 미 적용 응답속도 비교
</commit_message>
<xml_diff>
--- a/3.로컬 환경 SpringBoot+Redis.pptx
+++ b/3.로컬 환경 SpringBoot+Redis.pptx
@@ -14,6 +14,14 @@
     <p:sldId id="262" r:id="rId8"/>
     <p:sldId id="263" r:id="rId9"/>
     <p:sldId id="264" r:id="rId10"/>
+    <p:sldId id="265" r:id="rId11"/>
+    <p:sldId id="266" r:id="rId12"/>
+    <p:sldId id="267" r:id="rId13"/>
+    <p:sldId id="268" r:id="rId14"/>
+    <p:sldId id="270" r:id="rId15"/>
+    <p:sldId id="269" r:id="rId16"/>
+    <p:sldId id="271" r:id="rId17"/>
+    <p:sldId id="272" r:id="rId18"/>
   </p:sldIdLst>
   <p:sldSz cx="12192000" cy="6858000"/>
   <p:notesSz cx="6858000" cy="9144000"/>
@@ -132,7 +140,26 @@
             <p14:sldId id="264"/>
           </p14:sldIdLst>
         </p14:section>
+        <p14:section name="Redis 셋팅" id="{0E90D56B-1FF0-46C0-8794-162A834D2BED}">
+          <p14:sldIdLst>
+            <p14:sldId id="265"/>
+            <p14:sldId id="266"/>
+            <p14:sldId id="267"/>
+            <p14:sldId id="268"/>
+            <p14:sldId id="270"/>
+            <p14:sldId id="269"/>
+          </p14:sldIdLst>
+        </p14:section>
+        <p14:section name="캐시 미적용, 적용 응답시간 비교" id="{013CD2DA-236E-4F09-B401-0C3FC5747FAF}">
+          <p14:sldIdLst>
+            <p14:sldId id="271"/>
+            <p14:sldId id="272"/>
+          </p14:sldIdLst>
+        </p14:section>
       </p14:sectionLst>
+    </p:ext>
+    <p:ext uri="{EFAFB233-063F-42B5-8137-9DF3F51BA10A}">
+      <p15:sldGuideLst xmlns:p15="http://schemas.microsoft.com/office/powerpoint/2012/main"/>
     </p:ext>
   </p:extLst>
 </p:presentation>
@@ -364,7 +391,7 @@
           <a:p>
             <a:fld id="{F922853D-96C8-4D55-8417-23EB18CE17AF}" type="datetimeFigureOut">
               <a:rPr lang="ko-KR" altLang="en-US" smtClean="0"/>
-              <a:t>2026-08-24</a:t>
+              <a:t>2026-08-25</a:t>
             </a:fld>
             <a:endParaRPr lang="ko-KR" altLang="en-US"/>
           </a:p>
@@ -572,7 +599,7 @@
           <a:p>
             <a:fld id="{F922853D-96C8-4D55-8417-23EB18CE17AF}" type="datetimeFigureOut">
               <a:rPr lang="ko-KR" altLang="en-US" smtClean="0"/>
-              <a:t>2026-08-24</a:t>
+              <a:t>2026-08-25</a:t>
             </a:fld>
             <a:endParaRPr lang="ko-KR" altLang="en-US"/>
           </a:p>
@@ -828,7 +855,7 @@
           <a:p>
             <a:fld id="{F922853D-96C8-4D55-8417-23EB18CE17AF}" type="datetimeFigureOut">
               <a:rPr lang="ko-KR" altLang="en-US" smtClean="0"/>
-              <a:t>2026-08-24</a:t>
+              <a:t>2026-08-25</a:t>
             </a:fld>
             <a:endParaRPr lang="ko-KR" altLang="en-US"/>
           </a:p>
@@ -1002,7 +1029,7 @@
           <a:p>
             <a:fld id="{F922853D-96C8-4D55-8417-23EB18CE17AF}" type="datetimeFigureOut">
               <a:rPr lang="ko-KR" altLang="en-US" smtClean="0"/>
-              <a:t>2026-08-24</a:t>
+              <a:t>2026-08-25</a:t>
             </a:fld>
             <a:endParaRPr lang="ko-KR" altLang="en-US"/>
           </a:p>
@@ -1345,7 +1372,7 @@
           <a:p>
             <a:fld id="{F922853D-96C8-4D55-8417-23EB18CE17AF}" type="datetimeFigureOut">
               <a:rPr lang="ko-KR" altLang="en-US" smtClean="0"/>
-              <a:t>2026-08-24</a:t>
+              <a:t>2026-08-25</a:t>
             </a:fld>
             <a:endParaRPr lang="ko-KR" altLang="en-US"/>
           </a:p>
@@ -1620,7 +1647,7 @@
           <a:p>
             <a:fld id="{F922853D-96C8-4D55-8417-23EB18CE17AF}" type="datetimeFigureOut">
               <a:rPr lang="ko-KR" altLang="en-US" smtClean="0"/>
-              <a:t>2026-08-24</a:t>
+              <a:t>2026-08-25</a:t>
             </a:fld>
             <a:endParaRPr lang="ko-KR" altLang="en-US"/>
           </a:p>
@@ -1999,7 +2026,7 @@
           <a:p>
             <a:fld id="{F922853D-96C8-4D55-8417-23EB18CE17AF}" type="datetimeFigureOut">
               <a:rPr lang="ko-KR" altLang="en-US" smtClean="0"/>
-              <a:t>2026-08-24</a:t>
+              <a:t>2026-08-25</a:t>
             </a:fld>
             <a:endParaRPr lang="ko-KR" altLang="en-US"/>
           </a:p>
@@ -2117,7 +2144,7 @@
           <a:p>
             <a:fld id="{F922853D-96C8-4D55-8417-23EB18CE17AF}" type="datetimeFigureOut">
               <a:rPr lang="ko-KR" altLang="en-US" smtClean="0"/>
-              <a:t>2026-08-24</a:t>
+              <a:t>2026-08-25</a:t>
             </a:fld>
             <a:endParaRPr lang="ko-KR" altLang="en-US"/>
           </a:p>
@@ -2288,7 +2315,7 @@
           <a:p>
             <a:fld id="{F922853D-96C8-4D55-8417-23EB18CE17AF}" type="datetimeFigureOut">
               <a:rPr lang="ko-KR" altLang="en-US" smtClean="0"/>
-              <a:t>2026-08-24</a:t>
+              <a:t>2026-08-25</a:t>
             </a:fld>
             <a:endParaRPr lang="ko-KR" altLang="en-US"/>
           </a:p>
@@ -2642,7 +2669,7 @@
           <a:p>
             <a:fld id="{F922853D-96C8-4D55-8417-23EB18CE17AF}" type="datetimeFigureOut">
               <a:rPr lang="ko-KR" altLang="en-US" smtClean="0"/>
-              <a:t>2026-08-24</a:t>
+              <a:t>2026-08-25</a:t>
             </a:fld>
             <a:endParaRPr lang="ko-KR" altLang="en-US"/>
           </a:p>
@@ -3024,7 +3051,7 @@
           <a:p>
             <a:fld id="{F922853D-96C8-4D55-8417-23EB18CE17AF}" type="datetimeFigureOut">
               <a:rPr lang="ko-KR" altLang="en-US" smtClean="0"/>
-              <a:t>2026-08-24</a:t>
+              <a:t>2026-08-25</a:t>
             </a:fld>
             <a:endParaRPr lang="ko-KR" altLang="en-US"/>
           </a:p>
@@ -3311,7 +3338,7 @@
           <a:p>
             <a:fld id="{F922853D-96C8-4D55-8417-23EB18CE17AF}" type="datetimeFigureOut">
               <a:rPr lang="ko-KR" altLang="en-US" smtClean="0"/>
-              <a:t>2026-08-24</a:t>
+              <a:t>2026-08-25</a:t>
             </a:fld>
             <a:endParaRPr lang="ko-KR" altLang="en-US"/>
           </a:p>
@@ -3908,6 +3935,3228 @@
 </p:sld>
 </file>
 
+<file path=ppt/slides/slide10.xml><?xml version="1.0" encoding="utf-8"?>
+<p:sld xmlns:a="http://schemas.openxmlformats.org/drawingml/2006/main" xmlns:r="http://schemas.openxmlformats.org/officeDocument/2006/relationships" xmlns:p="http://schemas.openxmlformats.org/presentationml/2006/main">
+  <p:cSld>
+    <p:spTree>
+      <p:nvGrpSpPr>
+        <p:cNvPr id="1" name=""/>
+        <p:cNvGrpSpPr/>
+        <p:nvPr/>
+      </p:nvGrpSpPr>
+      <p:grpSpPr>
+        <a:xfrm>
+          <a:off x="0" y="0"/>
+          <a:ext cx="0" cy="0"/>
+          <a:chOff x="0" y="0"/>
+          <a:chExt cx="0" cy="0"/>
+        </a:xfrm>
+      </p:grpSpPr>
+      <p:sp>
+        <p:nvSpPr>
+          <p:cNvPr id="2" name="제목 1">
+            <a:extLst>
+              <a:ext uri="{FF2B5EF4-FFF2-40B4-BE49-F238E27FC236}">
+                <a16:creationId xmlns:a16="http://schemas.microsoft.com/office/drawing/2014/main" id="{DC0EFE84-041B-4B22-741E-622A667A0CFC}"/>
+              </a:ext>
+            </a:extLst>
+          </p:cNvPr>
+          <p:cNvSpPr>
+            <a:spLocks noGrp="1"/>
+          </p:cNvSpPr>
+          <p:nvPr>
+            <p:ph type="title"/>
+          </p:nvPr>
+        </p:nvSpPr>
+        <p:spPr/>
+        <p:txBody>
+          <a:bodyPr/>
+          <a:lstStyle/>
+          <a:p>
+            <a:r>
+              <a:rPr lang="en-US" altLang="ko-KR"/>
+              <a:t>Redis </a:t>
+            </a:r>
+            <a:r>
+              <a:rPr lang="ko-KR" altLang="en-US"/>
+              <a:t>의존성 추가</a:t>
+            </a:r>
+          </a:p>
+        </p:txBody>
+      </p:sp>
+      <p:sp>
+        <p:nvSpPr>
+          <p:cNvPr id="4" name="TextBox 3">
+            <a:extLst>
+              <a:ext uri="{FF2B5EF4-FFF2-40B4-BE49-F238E27FC236}">
+                <a16:creationId xmlns:a16="http://schemas.microsoft.com/office/drawing/2014/main" id="{012144ED-7177-4EBE-96E2-F1E9DA0D3ED6}"/>
+              </a:ext>
+            </a:extLst>
+          </p:cNvPr>
+          <p:cNvSpPr txBox="1"/>
+          <p:nvPr/>
+        </p:nvSpPr>
+        <p:spPr>
+          <a:xfrm>
+            <a:off x="1097280" y="2119853"/>
+            <a:ext cx="7850909" cy="523220"/>
+          </a:xfrm>
+          <a:prstGeom prst="rect">
+            <a:avLst/>
+          </a:prstGeom>
+          <a:noFill/>
+        </p:spPr>
+        <p:txBody>
+          <a:bodyPr wrap="square">
+            <a:spAutoFit/>
+          </a:bodyPr>
+          <a:lstStyle/>
+          <a:p>
+            <a:pPr marL="285750" indent="-285750">
+              <a:buFont typeface="Arial" panose="020B0604020202020204" pitchFamily="34" charset="0"/>
+              <a:buChar char="•"/>
+            </a:pPr>
+            <a:r>
+              <a:rPr lang="en-US" altLang="ko-KR" sz="1400"/>
+              <a:t>Redis </a:t>
+            </a:r>
+            <a:r>
+              <a:rPr lang="ko-KR" altLang="en-US" sz="1400"/>
+              <a:t>의존성</a:t>
+            </a:r>
+            <a:endParaRPr lang="en-US" altLang="ko-KR" sz="1400"/>
+          </a:p>
+          <a:p>
+            <a:r>
+              <a:rPr lang="en-US" altLang="ko-KR" sz="1400"/>
+              <a:t>implementation 'org.springframework.boot:spring-boot-starter-data-redis'</a:t>
+            </a:r>
+            <a:endParaRPr lang="ko-KR" altLang="en-US" sz="1400"/>
+          </a:p>
+        </p:txBody>
+      </p:sp>
+      <p:grpSp>
+        <p:nvGrpSpPr>
+          <p:cNvPr id="8" name="그룹 7">
+            <a:extLst>
+              <a:ext uri="{FF2B5EF4-FFF2-40B4-BE49-F238E27FC236}">
+                <a16:creationId xmlns:a16="http://schemas.microsoft.com/office/drawing/2014/main" id="{8B14EE97-961D-7A91-0711-1C41D8E43147}"/>
+              </a:ext>
+            </a:extLst>
+          </p:cNvPr>
+          <p:cNvGrpSpPr/>
+          <p:nvPr/>
+        </p:nvGrpSpPr>
+        <p:grpSpPr>
+          <a:xfrm>
+            <a:off x="1097280" y="2643074"/>
+            <a:ext cx="6273338" cy="1815494"/>
+            <a:chOff x="1097280" y="2643074"/>
+            <a:chExt cx="6273338" cy="1815494"/>
+          </a:xfrm>
+        </p:grpSpPr>
+        <p:pic>
+          <p:nvPicPr>
+            <p:cNvPr id="6" name="그림 5">
+              <a:extLst>
+                <a:ext uri="{FF2B5EF4-FFF2-40B4-BE49-F238E27FC236}">
+                  <a16:creationId xmlns:a16="http://schemas.microsoft.com/office/drawing/2014/main" id="{7ED6FA9D-329D-86CB-7A14-AD799DE873E5}"/>
+                </a:ext>
+              </a:extLst>
+            </p:cNvPr>
+            <p:cNvPicPr>
+              <a:picLocks noChangeAspect="1"/>
+            </p:cNvPicPr>
+            <p:nvPr/>
+          </p:nvPicPr>
+          <p:blipFill>
+            <a:blip r:embed="rId2"/>
+            <a:stretch>
+              <a:fillRect/>
+            </a:stretch>
+          </p:blipFill>
+          <p:spPr>
+            <a:xfrm>
+              <a:off x="1097280" y="2643074"/>
+              <a:ext cx="6273338" cy="1815494"/>
+            </a:xfrm>
+            <a:prstGeom prst="rect">
+              <a:avLst/>
+            </a:prstGeom>
+          </p:spPr>
+        </p:pic>
+        <p:sp>
+          <p:nvSpPr>
+            <p:cNvPr id="7" name="직사각형 6">
+              <a:extLst>
+                <a:ext uri="{FF2B5EF4-FFF2-40B4-BE49-F238E27FC236}">
+                  <a16:creationId xmlns:a16="http://schemas.microsoft.com/office/drawing/2014/main" id="{89B20FE9-BE96-3A70-EBEE-F6F0C050BFC3}"/>
+                </a:ext>
+              </a:extLst>
+            </p:cNvPr>
+            <p:cNvSpPr/>
+            <p:nvPr/>
+          </p:nvSpPr>
+          <p:spPr>
+            <a:xfrm>
+              <a:off x="1856509" y="3177309"/>
+              <a:ext cx="5070764" cy="251691"/>
+            </a:xfrm>
+            <a:prstGeom prst="rect">
+              <a:avLst/>
+            </a:prstGeom>
+            <a:noFill/>
+            <a:ln>
+              <a:solidFill>
+                <a:srgbClr val="FF0000"/>
+              </a:solidFill>
+            </a:ln>
+          </p:spPr>
+          <p:style>
+            <a:lnRef idx="2">
+              <a:schemeClr val="accent1">
+                <a:shade val="15000"/>
+              </a:schemeClr>
+            </a:lnRef>
+            <a:fillRef idx="1">
+              <a:schemeClr val="accent1"/>
+            </a:fillRef>
+            <a:effectRef idx="0">
+              <a:schemeClr val="accent1"/>
+            </a:effectRef>
+            <a:fontRef idx="minor">
+              <a:schemeClr val="lt1"/>
+            </a:fontRef>
+          </p:style>
+          <p:txBody>
+            <a:bodyPr rtlCol="0" anchor="ctr"/>
+            <a:lstStyle/>
+            <a:p>
+              <a:pPr algn="ctr"/>
+              <a:endParaRPr lang="ko-KR" altLang="en-US"/>
+            </a:p>
+          </p:txBody>
+        </p:sp>
+      </p:grpSp>
+      <p:pic>
+        <p:nvPicPr>
+          <p:cNvPr id="10" name="그림 9">
+            <a:extLst>
+              <a:ext uri="{FF2B5EF4-FFF2-40B4-BE49-F238E27FC236}">
+                <a16:creationId xmlns:a16="http://schemas.microsoft.com/office/drawing/2014/main" id="{160D4CC7-69DE-D115-C485-240E640DEBC5}"/>
+              </a:ext>
+            </a:extLst>
+          </p:cNvPr>
+          <p:cNvPicPr>
+            <a:picLocks noChangeAspect="1"/>
+          </p:cNvPicPr>
+          <p:nvPr/>
+        </p:nvPicPr>
+        <p:blipFill>
+          <a:blip r:embed="rId3"/>
+          <a:stretch>
+            <a:fillRect/>
+          </a:stretch>
+        </p:blipFill>
+        <p:spPr>
+          <a:xfrm>
+            <a:off x="7600611" y="1931324"/>
+            <a:ext cx="2277548" cy="4368538"/>
+          </a:xfrm>
+          <a:prstGeom prst="rect">
+            <a:avLst/>
+          </a:prstGeom>
+        </p:spPr>
+      </p:pic>
+      <p:sp>
+        <p:nvSpPr>
+          <p:cNvPr id="14" name="TextBox 13">
+            <a:extLst>
+              <a:ext uri="{FF2B5EF4-FFF2-40B4-BE49-F238E27FC236}">
+                <a16:creationId xmlns:a16="http://schemas.microsoft.com/office/drawing/2014/main" id="{3965ABC2-9DB0-A70F-F55F-062762D41C63}"/>
+              </a:ext>
+            </a:extLst>
+          </p:cNvPr>
+          <p:cNvSpPr txBox="1"/>
+          <p:nvPr/>
+        </p:nvSpPr>
+        <p:spPr>
+          <a:xfrm>
+            <a:off x="1097280" y="4604020"/>
+            <a:ext cx="6096000" cy="1200329"/>
+          </a:xfrm>
+          <a:prstGeom prst="rect">
+            <a:avLst/>
+          </a:prstGeom>
+          <a:noFill/>
+        </p:spPr>
+        <p:txBody>
+          <a:bodyPr wrap="square">
+            <a:spAutoFit/>
+          </a:bodyPr>
+          <a:lstStyle/>
+          <a:p>
+            <a:r>
+              <a:rPr lang="en-US" altLang="ko-KR">
+                <a:latin typeface="anthropic-mono"/>
+              </a:rPr>
+              <a:t>bootRun</a:t>
+            </a:r>
+            <a:r>
+              <a:rPr lang="ko-KR" altLang="en-US">
+                <a:latin typeface="anthropic-mono"/>
+              </a:rPr>
+              <a:t>을 실행시키거나 </a:t>
+            </a:r>
+            <a:endParaRPr lang="en-US" altLang="ko-KR" b="0" i="0" u="none" strike="noStrike">
+              <a:effectLst/>
+              <a:latin typeface="anthropic-mono"/>
+            </a:endParaRPr>
+          </a:p>
+          <a:p>
+            <a:endParaRPr lang="en-US" altLang="ko-KR" b="0" i="0" u="none" strike="noStrike">
+              <a:effectLst/>
+              <a:latin typeface="anthropic-mono"/>
+            </a:endParaRPr>
+          </a:p>
+          <a:p>
+            <a:r>
+              <a:rPr lang="en-US" altLang="ko-KR" b="0" i="0" u="none" strike="noStrike">
+                <a:effectLst/>
+                <a:latin typeface="anthropic-mono"/>
+              </a:rPr>
+              <a:t>gradlew compileJava </a:t>
+            </a:r>
+            <a:endParaRPr lang="en-US" altLang="ko-KR">
+              <a:latin typeface="anthropic-mono"/>
+            </a:endParaRPr>
+          </a:p>
+          <a:p>
+            <a:r>
+              <a:rPr lang="en-US" altLang="ko-KR" b="0" i="0" u="none" strike="noStrike">
+                <a:effectLst/>
+                <a:latin typeface="anthropic-mono"/>
+              </a:rPr>
+              <a:t>(</a:t>
+            </a:r>
+            <a:r>
+              <a:rPr lang="ko-KR" altLang="en-US" b="0" i="0" u="none" strike="noStrike">
+                <a:effectLst/>
+                <a:latin typeface="anthropic-mono"/>
+              </a:rPr>
+              <a:t>터미널에서 이거 실행시켜도 됨</a:t>
+            </a:r>
+            <a:r>
+              <a:rPr lang="en-US" altLang="ko-KR" b="0" i="0" u="none" strike="noStrike">
+                <a:effectLst/>
+                <a:latin typeface="anthropic-mono"/>
+              </a:rPr>
+              <a:t>)</a:t>
+            </a:r>
+            <a:endParaRPr lang="ko-KR" altLang="en-US"/>
+          </a:p>
+        </p:txBody>
+      </p:sp>
+    </p:spTree>
+    <p:extLst>
+      <p:ext uri="{BB962C8B-B14F-4D97-AF65-F5344CB8AC3E}">
+        <p14:creationId xmlns:p14="http://schemas.microsoft.com/office/powerpoint/2010/main" val="402370511"/>
+      </p:ext>
+    </p:extLst>
+  </p:cSld>
+  <p:clrMapOvr>
+    <a:masterClrMapping/>
+  </p:clrMapOvr>
+</p:sld>
+</file>
+
+<file path=ppt/slides/slide11.xml><?xml version="1.0" encoding="utf-8"?>
+<p:sld xmlns:a="http://schemas.openxmlformats.org/drawingml/2006/main" xmlns:r="http://schemas.openxmlformats.org/officeDocument/2006/relationships" xmlns:p="http://schemas.openxmlformats.org/presentationml/2006/main">
+  <p:cSld>
+    <p:spTree>
+      <p:nvGrpSpPr>
+        <p:cNvPr id="1" name=""/>
+        <p:cNvGrpSpPr/>
+        <p:nvPr/>
+      </p:nvGrpSpPr>
+      <p:grpSpPr>
+        <a:xfrm>
+          <a:off x="0" y="0"/>
+          <a:ext cx="0" cy="0"/>
+          <a:chOff x="0" y="0"/>
+          <a:chExt cx="0" cy="0"/>
+        </a:xfrm>
+      </p:grpSpPr>
+      <p:sp>
+        <p:nvSpPr>
+          <p:cNvPr id="2" name="제목 1">
+            <a:extLst>
+              <a:ext uri="{FF2B5EF4-FFF2-40B4-BE49-F238E27FC236}">
+                <a16:creationId xmlns:a16="http://schemas.microsoft.com/office/drawing/2014/main" id="{AFC6CBFC-5BA8-89E7-48CF-09310B0743EF}"/>
+              </a:ext>
+            </a:extLst>
+          </p:cNvPr>
+          <p:cNvSpPr>
+            <a:spLocks noGrp="1"/>
+          </p:cNvSpPr>
+          <p:nvPr>
+            <p:ph type="title"/>
+          </p:nvPr>
+        </p:nvSpPr>
+        <p:spPr/>
+        <p:txBody>
+          <a:bodyPr/>
+          <a:lstStyle/>
+          <a:p>
+            <a:r>
+              <a:rPr lang="en-US" altLang="ko-KR"/>
+              <a:t>application.yml Redis </a:t>
+            </a:r>
+            <a:r>
+              <a:rPr lang="ko-KR" altLang="en-US"/>
+              <a:t>셋팅</a:t>
+            </a:r>
+          </a:p>
+        </p:txBody>
+      </p:sp>
+      <p:grpSp>
+        <p:nvGrpSpPr>
+          <p:cNvPr id="5" name="그룹 4">
+            <a:extLst>
+              <a:ext uri="{FF2B5EF4-FFF2-40B4-BE49-F238E27FC236}">
+                <a16:creationId xmlns:a16="http://schemas.microsoft.com/office/drawing/2014/main" id="{8B4C534D-2988-644F-B934-5A3EDADB43BC}"/>
+              </a:ext>
+            </a:extLst>
+          </p:cNvPr>
+          <p:cNvGrpSpPr/>
+          <p:nvPr/>
+        </p:nvGrpSpPr>
+        <p:grpSpPr>
+          <a:xfrm>
+            <a:off x="1097280" y="1802012"/>
+            <a:ext cx="2334114" cy="5010563"/>
+            <a:chOff x="1097280" y="1802012"/>
+            <a:chExt cx="2334114" cy="5010563"/>
+          </a:xfrm>
+        </p:grpSpPr>
+        <p:pic>
+          <p:nvPicPr>
+            <p:cNvPr id="6" name="그림 5">
+              <a:extLst>
+                <a:ext uri="{FF2B5EF4-FFF2-40B4-BE49-F238E27FC236}">
+                  <a16:creationId xmlns:a16="http://schemas.microsoft.com/office/drawing/2014/main" id="{86860102-EFD1-B3B6-56CD-AC09F017D93D}"/>
+                </a:ext>
+              </a:extLst>
+            </p:cNvPr>
+            <p:cNvPicPr>
+              <a:picLocks noChangeAspect="1"/>
+            </p:cNvPicPr>
+            <p:nvPr/>
+          </p:nvPicPr>
+          <p:blipFill>
+            <a:blip r:embed="rId2"/>
+            <a:stretch>
+              <a:fillRect/>
+            </a:stretch>
+          </p:blipFill>
+          <p:spPr>
+            <a:xfrm>
+              <a:off x="1097280" y="1802012"/>
+              <a:ext cx="2334114" cy="5010563"/>
+            </a:xfrm>
+            <a:prstGeom prst="rect">
+              <a:avLst/>
+            </a:prstGeom>
+          </p:spPr>
+        </p:pic>
+        <p:sp>
+          <p:nvSpPr>
+            <p:cNvPr id="7" name="직사각형 6">
+              <a:extLst>
+                <a:ext uri="{FF2B5EF4-FFF2-40B4-BE49-F238E27FC236}">
+                  <a16:creationId xmlns:a16="http://schemas.microsoft.com/office/drawing/2014/main" id="{7DDC4BD3-569D-96B5-B3C9-51828FC695B2}"/>
+                </a:ext>
+              </a:extLst>
+            </p:cNvPr>
+            <p:cNvSpPr/>
+            <p:nvPr/>
+          </p:nvSpPr>
+          <p:spPr>
+            <a:xfrm>
+              <a:off x="1394691" y="5172361"/>
+              <a:ext cx="1126836" cy="230909"/>
+            </a:xfrm>
+            <a:prstGeom prst="rect">
+              <a:avLst/>
+            </a:prstGeom>
+            <a:noFill/>
+            <a:ln>
+              <a:solidFill>
+                <a:srgbClr val="FF0000"/>
+              </a:solidFill>
+            </a:ln>
+          </p:spPr>
+          <p:style>
+            <a:lnRef idx="2">
+              <a:schemeClr val="accent1">
+                <a:shade val="15000"/>
+              </a:schemeClr>
+            </a:lnRef>
+            <a:fillRef idx="1">
+              <a:schemeClr val="accent1"/>
+            </a:fillRef>
+            <a:effectRef idx="0">
+              <a:schemeClr val="accent1"/>
+            </a:effectRef>
+            <a:fontRef idx="minor">
+              <a:schemeClr val="lt1"/>
+            </a:fontRef>
+          </p:style>
+          <p:txBody>
+            <a:bodyPr rtlCol="0" anchor="ctr"/>
+            <a:lstStyle/>
+            <a:p>
+              <a:pPr algn="ctr"/>
+              <a:endParaRPr lang="ko-KR" altLang="en-US"/>
+            </a:p>
+          </p:txBody>
+        </p:sp>
+      </p:grpSp>
+      <p:grpSp>
+        <p:nvGrpSpPr>
+          <p:cNvPr id="4" name="그룹 3">
+            <a:extLst>
+              <a:ext uri="{FF2B5EF4-FFF2-40B4-BE49-F238E27FC236}">
+                <a16:creationId xmlns:a16="http://schemas.microsoft.com/office/drawing/2014/main" id="{B05952E4-ABA7-7A44-097D-7B2A8B0DD494}"/>
+              </a:ext>
+            </a:extLst>
+          </p:cNvPr>
+          <p:cNvGrpSpPr/>
+          <p:nvPr/>
+        </p:nvGrpSpPr>
+        <p:grpSpPr>
+          <a:xfrm>
+            <a:off x="3681075" y="1802012"/>
+            <a:ext cx="4829849" cy="4772691"/>
+            <a:chOff x="3681075" y="1802012"/>
+            <a:chExt cx="4829849" cy="4772691"/>
+          </a:xfrm>
+        </p:grpSpPr>
+        <p:pic>
+          <p:nvPicPr>
+            <p:cNvPr id="9" name="그림 8">
+              <a:extLst>
+                <a:ext uri="{FF2B5EF4-FFF2-40B4-BE49-F238E27FC236}">
+                  <a16:creationId xmlns:a16="http://schemas.microsoft.com/office/drawing/2014/main" id="{6CB79468-4175-C873-9801-DC23C93573B8}"/>
+                </a:ext>
+              </a:extLst>
+            </p:cNvPr>
+            <p:cNvPicPr>
+              <a:picLocks noChangeAspect="1"/>
+            </p:cNvPicPr>
+            <p:nvPr/>
+          </p:nvPicPr>
+          <p:blipFill>
+            <a:blip r:embed="rId3"/>
+            <a:stretch>
+              <a:fillRect/>
+            </a:stretch>
+          </p:blipFill>
+          <p:spPr>
+            <a:xfrm>
+              <a:off x="3681075" y="1802012"/>
+              <a:ext cx="4829849" cy="4772691"/>
+            </a:xfrm>
+            <a:prstGeom prst="rect">
+              <a:avLst/>
+            </a:prstGeom>
+          </p:spPr>
+        </p:pic>
+        <p:sp>
+          <p:nvSpPr>
+            <p:cNvPr id="3" name="직사각형 2">
+              <a:extLst>
+                <a:ext uri="{FF2B5EF4-FFF2-40B4-BE49-F238E27FC236}">
+                  <a16:creationId xmlns:a16="http://schemas.microsoft.com/office/drawing/2014/main" id="{B7E69311-D508-D192-6079-ECEBCCBFFAA8}"/>
+                </a:ext>
+              </a:extLst>
+            </p:cNvPr>
+            <p:cNvSpPr/>
+            <p:nvPr/>
+          </p:nvSpPr>
+          <p:spPr>
+            <a:xfrm>
+              <a:off x="4590473" y="5024582"/>
+              <a:ext cx="1801091" cy="785091"/>
+            </a:xfrm>
+            <a:prstGeom prst="rect">
+              <a:avLst/>
+            </a:prstGeom>
+            <a:noFill/>
+            <a:ln>
+              <a:solidFill>
+                <a:srgbClr val="FF0000"/>
+              </a:solidFill>
+            </a:ln>
+          </p:spPr>
+          <p:style>
+            <a:lnRef idx="2">
+              <a:schemeClr val="accent1">
+                <a:shade val="15000"/>
+              </a:schemeClr>
+            </a:lnRef>
+            <a:fillRef idx="1">
+              <a:schemeClr val="accent1"/>
+            </a:fillRef>
+            <a:effectRef idx="0">
+              <a:schemeClr val="accent1"/>
+            </a:effectRef>
+            <a:fontRef idx="minor">
+              <a:schemeClr val="lt1"/>
+            </a:fontRef>
+          </p:style>
+          <p:txBody>
+            <a:bodyPr rtlCol="0" anchor="ctr"/>
+            <a:lstStyle/>
+            <a:p>
+              <a:pPr algn="ctr"/>
+              <a:endParaRPr lang="ko-KR" altLang="en-US"/>
+            </a:p>
+          </p:txBody>
+        </p:sp>
+      </p:grpSp>
+      <p:sp>
+        <p:nvSpPr>
+          <p:cNvPr id="8" name="TextBox 7">
+            <a:extLst>
+              <a:ext uri="{FF2B5EF4-FFF2-40B4-BE49-F238E27FC236}">
+                <a16:creationId xmlns:a16="http://schemas.microsoft.com/office/drawing/2014/main" id="{5D4798A8-5653-6FE5-AACA-0AFF700725BB}"/>
+              </a:ext>
+            </a:extLst>
+          </p:cNvPr>
+          <p:cNvSpPr txBox="1"/>
+          <p:nvPr/>
+        </p:nvSpPr>
+        <p:spPr>
+          <a:xfrm>
+            <a:off x="8746836" y="1802012"/>
+            <a:ext cx="3232728" cy="2677656"/>
+          </a:xfrm>
+          <a:prstGeom prst="rect">
+            <a:avLst/>
+          </a:prstGeom>
+          <a:noFill/>
+        </p:spPr>
+        <p:txBody>
+          <a:bodyPr wrap="square" rtlCol="0">
+            <a:spAutoFit/>
+          </a:bodyPr>
+          <a:lstStyle/>
+          <a:p>
+            <a:r>
+              <a:rPr lang="ko-KR" altLang="en-US" sz="1400" b="1">
+                <a:solidFill>
+                  <a:srgbClr val="FF0000"/>
+                </a:solidFill>
+              </a:rPr>
+              <a:t>구버전 </a:t>
+            </a:r>
+            <a:r>
+              <a:rPr lang="en-US" altLang="ko-KR" sz="1400" b="1">
+                <a:solidFill>
+                  <a:srgbClr val="FF0000"/>
+                </a:solidFill>
+              </a:rPr>
+              <a:t>Redis </a:t>
+            </a:r>
+            <a:r>
+              <a:rPr lang="ko-KR" altLang="en-US" sz="1400" b="1">
+                <a:solidFill>
+                  <a:srgbClr val="FF0000"/>
+                </a:solidFill>
+              </a:rPr>
+              <a:t>설정</a:t>
+            </a:r>
+            <a:endParaRPr lang="en-US" altLang="ko-KR" sz="1400" b="1">
+              <a:solidFill>
+                <a:srgbClr val="FF0000"/>
+              </a:solidFill>
+            </a:endParaRPr>
+          </a:p>
+          <a:p>
+            <a:r>
+              <a:rPr lang="en-US" altLang="ko-KR" sz="1400"/>
+              <a:t>spring:</a:t>
+            </a:r>
+          </a:p>
+          <a:p>
+            <a:r>
+              <a:rPr lang="en-US" altLang="ko-KR" sz="1400"/>
+              <a:t>	redis:</a:t>
+            </a:r>
+          </a:p>
+          <a:p>
+            <a:r>
+              <a:rPr lang="en-US" altLang="ko-KR" sz="1400"/>
+              <a:t>		host: ~~</a:t>
+            </a:r>
+          </a:p>
+          <a:p>
+            <a:r>
+              <a:rPr lang="en-US" altLang="ko-KR" sz="1400"/>
+              <a:t>		port: ~~</a:t>
+            </a:r>
+          </a:p>
+          <a:p>
+            <a:endParaRPr lang="en-US" altLang="ko-KR" sz="1400"/>
+          </a:p>
+          <a:p>
+            <a:r>
+              <a:rPr lang="ko-KR" altLang="en-US" sz="1400" b="1">
+                <a:solidFill>
+                  <a:srgbClr val="FF0000"/>
+                </a:solidFill>
+              </a:rPr>
+              <a:t>현재</a:t>
+            </a:r>
+            <a:r>
+              <a:rPr lang="en-US" altLang="ko-KR" sz="1400" b="1">
+                <a:solidFill>
+                  <a:srgbClr val="FF0000"/>
+                </a:solidFill>
+              </a:rPr>
+              <a:t>(2026/08/25 </a:t>
+            </a:r>
+            <a:r>
+              <a:rPr lang="ko-KR" altLang="en-US" sz="1400" b="1">
+                <a:solidFill>
+                  <a:srgbClr val="FF0000"/>
+                </a:solidFill>
+              </a:rPr>
+              <a:t>기준</a:t>
+            </a:r>
+            <a:r>
+              <a:rPr lang="en-US" altLang="ko-KR" sz="1400" b="1">
+                <a:solidFill>
+                  <a:srgbClr val="FF0000"/>
+                </a:solidFill>
+              </a:rPr>
+              <a:t>)</a:t>
+            </a:r>
+          </a:p>
+          <a:p>
+            <a:r>
+              <a:rPr lang="en-US" altLang="ko-KR" sz="1400"/>
+              <a:t>spring:</a:t>
+            </a:r>
+          </a:p>
+          <a:p>
+            <a:r>
+              <a:rPr lang="en-US" altLang="ko-KR" sz="1400"/>
+              <a:t>	data:</a:t>
+            </a:r>
+          </a:p>
+          <a:p>
+            <a:r>
+              <a:rPr lang="en-US" altLang="ko-KR" sz="1400"/>
+              <a:t>		redis:</a:t>
+            </a:r>
+          </a:p>
+          <a:p>
+            <a:r>
+              <a:rPr lang="en-US" altLang="ko-KR" sz="1400"/>
+              <a:t>			host: ~~</a:t>
+            </a:r>
+          </a:p>
+          <a:p>
+            <a:r>
+              <a:rPr lang="en-US" altLang="ko-KR" sz="1400"/>
+              <a:t>			port: ~~</a:t>
+            </a:r>
+            <a:endParaRPr lang="ko-KR" altLang="en-US" sz="1400"/>
+          </a:p>
+        </p:txBody>
+      </p:sp>
+    </p:spTree>
+    <p:extLst>
+      <p:ext uri="{BB962C8B-B14F-4D97-AF65-F5344CB8AC3E}">
+        <p14:creationId xmlns:p14="http://schemas.microsoft.com/office/powerpoint/2010/main" val="909618795"/>
+      </p:ext>
+    </p:extLst>
+  </p:cSld>
+  <p:clrMapOvr>
+    <a:masterClrMapping/>
+  </p:clrMapOvr>
+</p:sld>
+</file>
+
+<file path=ppt/slides/slide12.xml><?xml version="1.0" encoding="utf-8"?>
+<p:sld xmlns:a="http://schemas.openxmlformats.org/drawingml/2006/main" xmlns:r="http://schemas.openxmlformats.org/officeDocument/2006/relationships" xmlns:p="http://schemas.openxmlformats.org/presentationml/2006/main">
+  <p:cSld>
+    <p:spTree>
+      <p:nvGrpSpPr>
+        <p:cNvPr id="1" name=""/>
+        <p:cNvGrpSpPr/>
+        <p:nvPr/>
+      </p:nvGrpSpPr>
+      <p:grpSpPr>
+        <a:xfrm>
+          <a:off x="0" y="0"/>
+          <a:ext cx="0" cy="0"/>
+          <a:chOff x="0" y="0"/>
+          <a:chExt cx="0" cy="0"/>
+        </a:xfrm>
+      </p:grpSpPr>
+      <p:sp>
+        <p:nvSpPr>
+          <p:cNvPr id="2" name="제목 1">
+            <a:extLst>
+              <a:ext uri="{FF2B5EF4-FFF2-40B4-BE49-F238E27FC236}">
+                <a16:creationId xmlns:a16="http://schemas.microsoft.com/office/drawing/2014/main" id="{45A14D27-439C-16ED-16C5-70B9CCDDE940}"/>
+              </a:ext>
+            </a:extLst>
+          </p:cNvPr>
+          <p:cNvSpPr>
+            <a:spLocks noGrp="1"/>
+          </p:cNvSpPr>
+          <p:nvPr>
+            <p:ph type="title"/>
+          </p:nvPr>
+        </p:nvSpPr>
+        <p:spPr/>
+        <p:txBody>
+          <a:bodyPr/>
+          <a:lstStyle/>
+          <a:p>
+            <a:r>
+              <a:rPr lang="en-US" altLang="ko-KR"/>
+              <a:t>RedisConfig </a:t>
+            </a:r>
+            <a:r>
+              <a:rPr lang="ko-KR" altLang="en-US"/>
+              <a:t>파일 작성</a:t>
+            </a:r>
+          </a:p>
+        </p:txBody>
+      </p:sp>
+      <p:grpSp>
+        <p:nvGrpSpPr>
+          <p:cNvPr id="3" name="그룹 2">
+            <a:extLst>
+              <a:ext uri="{FF2B5EF4-FFF2-40B4-BE49-F238E27FC236}">
+                <a16:creationId xmlns:a16="http://schemas.microsoft.com/office/drawing/2014/main" id="{F85BF542-5BE7-73A1-FF18-EC4DBCA3F785}"/>
+              </a:ext>
+            </a:extLst>
+          </p:cNvPr>
+          <p:cNvGrpSpPr/>
+          <p:nvPr/>
+        </p:nvGrpSpPr>
+        <p:grpSpPr>
+          <a:xfrm>
+            <a:off x="308494" y="1893454"/>
+            <a:ext cx="2043084" cy="4849598"/>
+            <a:chOff x="1097280" y="1893454"/>
+            <a:chExt cx="2043084" cy="4849598"/>
+          </a:xfrm>
+        </p:grpSpPr>
+        <p:pic>
+          <p:nvPicPr>
+            <p:cNvPr id="4" name="그림 3">
+              <a:extLst>
+                <a:ext uri="{FF2B5EF4-FFF2-40B4-BE49-F238E27FC236}">
+                  <a16:creationId xmlns:a16="http://schemas.microsoft.com/office/drawing/2014/main" id="{BBEAD03C-7DCF-0433-C73A-B3C1A6AE3603}"/>
+                </a:ext>
+              </a:extLst>
+            </p:cNvPr>
+            <p:cNvPicPr>
+              <a:picLocks noChangeAspect="1"/>
+            </p:cNvPicPr>
+            <p:nvPr/>
+          </p:nvPicPr>
+          <p:blipFill>
+            <a:blip r:embed="rId2"/>
+            <a:stretch>
+              <a:fillRect/>
+            </a:stretch>
+          </p:blipFill>
+          <p:spPr>
+            <a:xfrm>
+              <a:off x="1097280" y="1893454"/>
+              <a:ext cx="2043084" cy="4849598"/>
+            </a:xfrm>
+            <a:prstGeom prst="rect">
+              <a:avLst/>
+            </a:prstGeom>
+          </p:spPr>
+        </p:pic>
+        <p:sp>
+          <p:nvSpPr>
+            <p:cNvPr id="5" name="직사각형 4">
+              <a:extLst>
+                <a:ext uri="{FF2B5EF4-FFF2-40B4-BE49-F238E27FC236}">
+                  <a16:creationId xmlns:a16="http://schemas.microsoft.com/office/drawing/2014/main" id="{18E2C042-0770-B4E0-BEAE-C1E99588F01C}"/>
+                </a:ext>
+              </a:extLst>
+            </p:cNvPr>
+            <p:cNvSpPr/>
+            <p:nvPr/>
+          </p:nvSpPr>
+          <p:spPr>
+            <a:xfrm>
+              <a:off x="1293091" y="3546761"/>
+              <a:ext cx="1089891" cy="341748"/>
+            </a:xfrm>
+            <a:prstGeom prst="rect">
+              <a:avLst/>
+            </a:prstGeom>
+            <a:noFill/>
+            <a:ln>
+              <a:solidFill>
+                <a:srgbClr val="FF0000"/>
+              </a:solidFill>
+            </a:ln>
+          </p:spPr>
+          <p:style>
+            <a:lnRef idx="2">
+              <a:schemeClr val="accent1">
+                <a:shade val="15000"/>
+              </a:schemeClr>
+            </a:lnRef>
+            <a:fillRef idx="1">
+              <a:schemeClr val="accent1"/>
+            </a:fillRef>
+            <a:effectRef idx="0">
+              <a:schemeClr val="accent1"/>
+            </a:effectRef>
+            <a:fontRef idx="minor">
+              <a:schemeClr val="lt1"/>
+            </a:fontRef>
+          </p:style>
+          <p:txBody>
+            <a:bodyPr rtlCol="0" anchor="ctr"/>
+            <a:lstStyle/>
+            <a:p>
+              <a:pPr algn="ctr"/>
+              <a:endParaRPr lang="ko-KR" altLang="en-US"/>
+            </a:p>
+          </p:txBody>
+        </p:sp>
+      </p:grpSp>
+      <p:pic>
+        <p:nvPicPr>
+          <p:cNvPr id="7" name="그림 6">
+            <a:extLst>
+              <a:ext uri="{FF2B5EF4-FFF2-40B4-BE49-F238E27FC236}">
+                <a16:creationId xmlns:a16="http://schemas.microsoft.com/office/drawing/2014/main" id="{F893FBDD-98C1-DDEC-CF53-48590577A89A}"/>
+              </a:ext>
+            </a:extLst>
+          </p:cNvPr>
+          <p:cNvPicPr>
+            <a:picLocks noChangeAspect="1"/>
+          </p:cNvPicPr>
+          <p:nvPr/>
+        </p:nvPicPr>
+        <p:blipFill>
+          <a:blip r:embed="rId3"/>
+          <a:stretch>
+            <a:fillRect/>
+          </a:stretch>
+        </p:blipFill>
+        <p:spPr>
+          <a:xfrm>
+            <a:off x="2440248" y="1893454"/>
+            <a:ext cx="5964685" cy="3528291"/>
+          </a:xfrm>
+          <a:prstGeom prst="rect">
+            <a:avLst/>
+          </a:prstGeom>
+        </p:spPr>
+      </p:pic>
+      <p:sp>
+        <p:nvSpPr>
+          <p:cNvPr id="8" name="TextBox 7">
+            <a:extLst>
+              <a:ext uri="{FF2B5EF4-FFF2-40B4-BE49-F238E27FC236}">
+                <a16:creationId xmlns:a16="http://schemas.microsoft.com/office/drawing/2014/main" id="{0C3509FF-0A11-C02B-C405-A89205ACB978}"/>
+              </a:ext>
+            </a:extLst>
+          </p:cNvPr>
+          <p:cNvSpPr txBox="1"/>
+          <p:nvPr/>
+        </p:nvSpPr>
+        <p:spPr>
+          <a:xfrm>
+            <a:off x="2440248" y="5439339"/>
+            <a:ext cx="7525789" cy="276999"/>
+          </a:xfrm>
+          <a:prstGeom prst="rect">
+            <a:avLst/>
+          </a:prstGeom>
+          <a:noFill/>
+        </p:spPr>
+        <p:txBody>
+          <a:bodyPr wrap="square" rtlCol="0">
+            <a:spAutoFit/>
+          </a:bodyPr>
+          <a:lstStyle/>
+          <a:p>
+            <a:r>
+              <a:rPr lang="en-US" altLang="ko-KR" sz="1200">
+                <a:sym typeface="Wingdings" panose="05000000000000000000" pitchFamily="2" charset="2"/>
+              </a:rPr>
+              <a:t> Lettuce </a:t>
+            </a:r>
+            <a:r>
+              <a:rPr lang="ko-KR" altLang="en-US" sz="1200">
+                <a:sym typeface="Wingdings" panose="05000000000000000000" pitchFamily="2" charset="2"/>
+              </a:rPr>
+              <a:t>라는 라이브러리를 통해 </a:t>
+            </a:r>
+            <a:r>
+              <a:rPr lang="en-US" altLang="ko-KR" sz="1200">
+                <a:sym typeface="Wingdings" panose="05000000000000000000" pitchFamily="2" charset="2"/>
+              </a:rPr>
+              <a:t>Redis </a:t>
+            </a:r>
+            <a:r>
+              <a:rPr lang="ko-KR" altLang="en-US" sz="1200">
+                <a:sym typeface="Wingdings" panose="05000000000000000000" pitchFamily="2" charset="2"/>
+              </a:rPr>
+              <a:t>관리 객체를 생성 </a:t>
+            </a:r>
+            <a:r>
+              <a:rPr lang="en-US" altLang="ko-KR" sz="1200">
+                <a:sym typeface="Wingdings" panose="05000000000000000000" pitchFamily="2" charset="2"/>
+              </a:rPr>
+              <a:t>&gt; Redis </a:t>
+            </a:r>
+            <a:r>
+              <a:rPr lang="ko-KR" altLang="en-US" sz="1200">
+                <a:sym typeface="Wingdings" panose="05000000000000000000" pitchFamily="2" charset="2"/>
+              </a:rPr>
+              <a:t>서버에 대한 정보를 설정한다</a:t>
+            </a:r>
+            <a:r>
+              <a:rPr lang="en-US" altLang="ko-KR" sz="1200">
+                <a:sym typeface="Wingdings" panose="05000000000000000000" pitchFamily="2" charset="2"/>
+              </a:rPr>
+              <a:t>.</a:t>
+            </a:r>
+            <a:endParaRPr lang="ko-KR" altLang="en-US" sz="1200"/>
+          </a:p>
+        </p:txBody>
+      </p:sp>
+      <p:sp>
+        <p:nvSpPr>
+          <p:cNvPr id="6" name="TextBox 5">
+            <a:extLst>
+              <a:ext uri="{FF2B5EF4-FFF2-40B4-BE49-F238E27FC236}">
+                <a16:creationId xmlns:a16="http://schemas.microsoft.com/office/drawing/2014/main" id="{6299F9AD-AB45-EFF0-54C5-A8FC7D299EE3}"/>
+              </a:ext>
+            </a:extLst>
+          </p:cNvPr>
+          <p:cNvSpPr txBox="1"/>
+          <p:nvPr/>
+        </p:nvSpPr>
+        <p:spPr>
+          <a:xfrm>
+            <a:off x="8562109" y="1893454"/>
+            <a:ext cx="3389746" cy="1384995"/>
+          </a:xfrm>
+          <a:prstGeom prst="rect">
+            <a:avLst/>
+          </a:prstGeom>
+          <a:noFill/>
+        </p:spPr>
+        <p:txBody>
+          <a:bodyPr wrap="square" rtlCol="0">
+            <a:spAutoFit/>
+          </a:bodyPr>
+          <a:lstStyle/>
+          <a:p>
+            <a:pPr marL="285750" indent="-285750">
+              <a:buFont typeface="Arial" panose="020B0604020202020204" pitchFamily="34" charset="0"/>
+              <a:buChar char="•"/>
+            </a:pPr>
+            <a:r>
+              <a:rPr lang="en-US" altLang="ko-KR" sz="1400" b="1">
+                <a:solidFill>
+                  <a:srgbClr val="FF0000"/>
+                </a:solidFill>
+              </a:rPr>
+              <a:t>LettuceConnectionFactory</a:t>
+            </a:r>
+          </a:p>
+          <a:p>
+            <a:pPr marL="285750" indent="-285750">
+              <a:buFontTx/>
+              <a:buChar char="-"/>
+            </a:pPr>
+            <a:r>
+              <a:rPr lang="en-US" altLang="ko-KR" sz="1400"/>
+              <a:t>Redis</a:t>
+            </a:r>
+            <a:r>
+              <a:rPr lang="ko-KR" altLang="en-US" sz="1400"/>
+              <a:t>와 연결해주는 객체</a:t>
+            </a:r>
+            <a:endParaRPr lang="en-US" altLang="ko-KR" sz="1400"/>
+          </a:p>
+          <a:p>
+            <a:pPr marL="285750" indent="-285750">
+              <a:buFont typeface="Arial" panose="020B0604020202020204" pitchFamily="34" charset="0"/>
+              <a:buChar char="•"/>
+            </a:pPr>
+            <a:r>
+              <a:rPr lang="en-US" altLang="ko-KR" sz="1400" b="1">
+                <a:solidFill>
+                  <a:srgbClr val="FF0000"/>
+                </a:solidFill>
+              </a:rPr>
+              <a:t>RedisStandaloneConfiguration</a:t>
+            </a:r>
+          </a:p>
+          <a:p>
+            <a:pPr marL="285750" indent="-285750">
+              <a:buFontTx/>
+              <a:buChar char="-"/>
+            </a:pPr>
+            <a:r>
+              <a:rPr lang="en-US" altLang="ko-KR" sz="1400"/>
+              <a:t>Redis</a:t>
+            </a:r>
+            <a:r>
+              <a:rPr lang="ko-KR" altLang="en-US" sz="1400"/>
+              <a:t>를 관리하는 객체</a:t>
+            </a:r>
+            <a:endParaRPr lang="en-US" altLang="ko-KR" sz="1400"/>
+          </a:p>
+          <a:p>
+            <a:endParaRPr lang="en-US" altLang="ko-KR" sz="1400"/>
+          </a:p>
+          <a:p>
+            <a:endParaRPr lang="ko-KR" altLang="en-US" sz="1400"/>
+          </a:p>
+        </p:txBody>
+      </p:sp>
+      <p:sp>
+        <p:nvSpPr>
+          <p:cNvPr id="9" name="TextBox 8">
+            <a:extLst>
+              <a:ext uri="{FF2B5EF4-FFF2-40B4-BE49-F238E27FC236}">
+                <a16:creationId xmlns:a16="http://schemas.microsoft.com/office/drawing/2014/main" id="{C2FF95E3-0C08-60C2-2921-D6A9908A7928}"/>
+              </a:ext>
+            </a:extLst>
+          </p:cNvPr>
+          <p:cNvSpPr txBox="1"/>
+          <p:nvPr/>
+        </p:nvSpPr>
+        <p:spPr>
+          <a:xfrm>
+            <a:off x="8562109" y="3278449"/>
+            <a:ext cx="2835564" cy="369332"/>
+          </a:xfrm>
+          <a:prstGeom prst="rect">
+            <a:avLst/>
+          </a:prstGeom>
+          <a:noFill/>
+        </p:spPr>
+        <p:txBody>
+          <a:bodyPr wrap="square" rtlCol="0">
+            <a:spAutoFit/>
+          </a:bodyPr>
+          <a:lstStyle/>
+          <a:p>
+            <a:r>
+              <a:rPr lang="ko-KR" altLang="en-US"/>
+              <a:t>외우도록 노력하자</a:t>
+            </a:r>
+          </a:p>
+        </p:txBody>
+      </p:sp>
+    </p:spTree>
+    <p:extLst>
+      <p:ext uri="{BB962C8B-B14F-4D97-AF65-F5344CB8AC3E}">
+        <p14:creationId xmlns:p14="http://schemas.microsoft.com/office/powerpoint/2010/main" val="3105270326"/>
+      </p:ext>
+    </p:extLst>
+  </p:cSld>
+  <p:clrMapOvr>
+    <a:masterClrMapping/>
+  </p:clrMapOvr>
+</p:sld>
+</file>
+
+<file path=ppt/slides/slide13.xml><?xml version="1.0" encoding="utf-8"?>
+<p:sld xmlns:a="http://schemas.openxmlformats.org/drawingml/2006/main" xmlns:r="http://schemas.openxmlformats.org/officeDocument/2006/relationships" xmlns:p="http://schemas.openxmlformats.org/presentationml/2006/main">
+  <p:cSld>
+    <p:spTree>
+      <p:nvGrpSpPr>
+        <p:cNvPr id="1" name=""/>
+        <p:cNvGrpSpPr/>
+        <p:nvPr/>
+      </p:nvGrpSpPr>
+      <p:grpSpPr>
+        <a:xfrm>
+          <a:off x="0" y="0"/>
+          <a:ext cx="0" cy="0"/>
+          <a:chOff x="0" y="0"/>
+          <a:chExt cx="0" cy="0"/>
+        </a:xfrm>
+      </p:grpSpPr>
+      <p:sp>
+        <p:nvSpPr>
+          <p:cNvPr id="2" name="제목 1">
+            <a:extLst>
+              <a:ext uri="{FF2B5EF4-FFF2-40B4-BE49-F238E27FC236}">
+                <a16:creationId xmlns:a16="http://schemas.microsoft.com/office/drawing/2014/main" id="{A91454B8-9B9D-258E-38F4-847E0B11A635}"/>
+              </a:ext>
+            </a:extLst>
+          </p:cNvPr>
+          <p:cNvSpPr>
+            <a:spLocks noGrp="1"/>
+          </p:cNvSpPr>
+          <p:nvPr>
+            <p:ph type="title"/>
+          </p:nvPr>
+        </p:nvSpPr>
+        <p:spPr/>
+        <p:txBody>
+          <a:bodyPr/>
+          <a:lstStyle/>
+          <a:p>
+            <a:r>
+              <a:rPr lang="en-US" altLang="ko-KR"/>
+              <a:t>RedisCacheManager </a:t>
+            </a:r>
+            <a:r>
+              <a:rPr lang="ko-KR" altLang="en-US"/>
+              <a:t>작성</a:t>
+            </a:r>
+          </a:p>
+        </p:txBody>
+      </p:sp>
+      <p:pic>
+        <p:nvPicPr>
+          <p:cNvPr id="6" name="그림 5">
+            <a:extLst>
+              <a:ext uri="{FF2B5EF4-FFF2-40B4-BE49-F238E27FC236}">
+                <a16:creationId xmlns:a16="http://schemas.microsoft.com/office/drawing/2014/main" id="{A63BC557-80C4-AA1E-7E89-F5810550F5CD}"/>
+              </a:ext>
+            </a:extLst>
+          </p:cNvPr>
+          <p:cNvPicPr>
+            <a:picLocks noChangeAspect="1"/>
+          </p:cNvPicPr>
+          <p:nvPr/>
+        </p:nvPicPr>
+        <p:blipFill>
+          <a:blip r:embed="rId2"/>
+          <a:stretch>
+            <a:fillRect/>
+          </a:stretch>
+        </p:blipFill>
+        <p:spPr>
+          <a:xfrm>
+            <a:off x="3037517" y="1842519"/>
+            <a:ext cx="4780377" cy="3486863"/>
+          </a:xfrm>
+          <a:prstGeom prst="rect">
+            <a:avLst/>
+          </a:prstGeom>
+        </p:spPr>
+      </p:pic>
+      <p:grpSp>
+        <p:nvGrpSpPr>
+          <p:cNvPr id="10" name="그룹 9">
+            <a:extLst>
+              <a:ext uri="{FF2B5EF4-FFF2-40B4-BE49-F238E27FC236}">
+                <a16:creationId xmlns:a16="http://schemas.microsoft.com/office/drawing/2014/main" id="{474B6746-61B8-8F58-5D52-EC237B0545F5}"/>
+              </a:ext>
+            </a:extLst>
+          </p:cNvPr>
+          <p:cNvGrpSpPr/>
+          <p:nvPr/>
+        </p:nvGrpSpPr>
+        <p:grpSpPr>
+          <a:xfrm>
+            <a:off x="358018" y="1842519"/>
+            <a:ext cx="2572109" cy="4229690"/>
+            <a:chOff x="358018" y="1842519"/>
+            <a:chExt cx="2572109" cy="4229690"/>
+          </a:xfrm>
+        </p:grpSpPr>
+        <p:pic>
+          <p:nvPicPr>
+            <p:cNvPr id="8" name="그림 7">
+              <a:extLst>
+                <a:ext uri="{FF2B5EF4-FFF2-40B4-BE49-F238E27FC236}">
+                  <a16:creationId xmlns:a16="http://schemas.microsoft.com/office/drawing/2014/main" id="{EFC9FF0D-79CF-CBA4-121F-39EDCEFFADC9}"/>
+                </a:ext>
+              </a:extLst>
+            </p:cNvPr>
+            <p:cNvPicPr>
+              <a:picLocks noChangeAspect="1"/>
+            </p:cNvPicPr>
+            <p:nvPr/>
+          </p:nvPicPr>
+          <p:blipFill>
+            <a:blip r:embed="rId3"/>
+            <a:stretch>
+              <a:fillRect/>
+            </a:stretch>
+          </p:blipFill>
+          <p:spPr>
+            <a:xfrm>
+              <a:off x="358018" y="1842519"/>
+              <a:ext cx="2572109" cy="4229690"/>
+            </a:xfrm>
+            <a:prstGeom prst="rect">
+              <a:avLst/>
+            </a:prstGeom>
+          </p:spPr>
+        </p:pic>
+        <p:sp>
+          <p:nvSpPr>
+            <p:cNvPr id="9" name="직사각형 8">
+              <a:extLst>
+                <a:ext uri="{FF2B5EF4-FFF2-40B4-BE49-F238E27FC236}">
+                  <a16:creationId xmlns:a16="http://schemas.microsoft.com/office/drawing/2014/main" id="{56FDFC81-8F6F-E1DF-A6A1-3419FF81AC77}"/>
+                </a:ext>
+              </a:extLst>
+            </p:cNvPr>
+            <p:cNvSpPr/>
+            <p:nvPr/>
+          </p:nvSpPr>
+          <p:spPr>
+            <a:xfrm>
+              <a:off x="877453" y="4184073"/>
+              <a:ext cx="1496293" cy="267854"/>
+            </a:xfrm>
+            <a:prstGeom prst="rect">
+              <a:avLst/>
+            </a:prstGeom>
+            <a:noFill/>
+            <a:ln>
+              <a:solidFill>
+                <a:srgbClr val="FF0000"/>
+              </a:solidFill>
+            </a:ln>
+          </p:spPr>
+          <p:style>
+            <a:lnRef idx="2">
+              <a:schemeClr val="accent1">
+                <a:shade val="15000"/>
+              </a:schemeClr>
+            </a:lnRef>
+            <a:fillRef idx="1">
+              <a:schemeClr val="accent1"/>
+            </a:fillRef>
+            <a:effectRef idx="0">
+              <a:schemeClr val="accent1"/>
+            </a:effectRef>
+            <a:fontRef idx="minor">
+              <a:schemeClr val="lt1"/>
+            </a:fontRef>
+          </p:style>
+          <p:txBody>
+            <a:bodyPr rtlCol="0" anchor="ctr"/>
+            <a:lstStyle/>
+            <a:p>
+              <a:pPr algn="ctr"/>
+              <a:endParaRPr lang="ko-KR" altLang="en-US"/>
+            </a:p>
+          </p:txBody>
+        </p:sp>
+      </p:grpSp>
+      <p:sp>
+        <p:nvSpPr>
+          <p:cNvPr id="11" name="TextBox 10">
+            <a:extLst>
+              <a:ext uri="{FF2B5EF4-FFF2-40B4-BE49-F238E27FC236}">
+                <a16:creationId xmlns:a16="http://schemas.microsoft.com/office/drawing/2014/main" id="{C6302806-25E7-E3D3-F8E8-BEB88611D9A9}"/>
+              </a:ext>
+            </a:extLst>
+          </p:cNvPr>
+          <p:cNvSpPr txBox="1"/>
+          <p:nvPr/>
+        </p:nvSpPr>
+        <p:spPr>
+          <a:xfrm>
+            <a:off x="7925284" y="1842519"/>
+            <a:ext cx="4088989" cy="4616648"/>
+          </a:xfrm>
+          <a:prstGeom prst="rect">
+            <a:avLst/>
+          </a:prstGeom>
+          <a:noFill/>
+        </p:spPr>
+        <p:txBody>
+          <a:bodyPr wrap="square" rtlCol="0">
+            <a:spAutoFit/>
+          </a:bodyPr>
+          <a:lstStyle/>
+          <a:p>
+            <a:r>
+              <a:rPr lang="ko-KR" altLang="en-US" sz="1050" b="1">
+                <a:solidFill>
+                  <a:srgbClr val="FF0000"/>
+                </a:solidFill>
+              </a:rPr>
+              <a:t>키</a:t>
+            </a:r>
+            <a:r>
+              <a:rPr lang="en-US" altLang="ko-KR" sz="1050" b="1">
+                <a:solidFill>
+                  <a:srgbClr val="FF0000"/>
+                </a:solidFill>
+              </a:rPr>
+              <a:t>-</a:t>
+            </a:r>
+            <a:r>
+              <a:rPr lang="ko-KR" altLang="en-US" sz="1050" b="1">
+                <a:solidFill>
+                  <a:srgbClr val="FF0000"/>
+                </a:solidFill>
+              </a:rPr>
+              <a:t>값 캐시저장 시  직렬화</a:t>
+            </a:r>
+            <a:r>
+              <a:rPr lang="en-US" altLang="ko-KR" sz="1050" b="1">
+                <a:solidFill>
+                  <a:srgbClr val="FF0000"/>
+                </a:solidFill>
+              </a:rPr>
+              <a:t>, </a:t>
+            </a:r>
+            <a:r>
+              <a:rPr lang="ko-KR" altLang="en-US" sz="1050" b="1">
+                <a:solidFill>
+                  <a:srgbClr val="FF0000"/>
+                </a:solidFill>
+              </a:rPr>
+              <a:t>역직렬화 설정 파일</a:t>
+            </a:r>
+            <a:br>
+              <a:rPr lang="en-US" altLang="ko-KR" sz="1050" b="1">
+                <a:solidFill>
+                  <a:srgbClr val="FF0000"/>
+                </a:solidFill>
+              </a:rPr>
+            </a:br>
+            <a:endParaRPr lang="en-US" altLang="ko-KR" sz="1050" b="1">
+              <a:solidFill>
+                <a:srgbClr val="FF0000"/>
+              </a:solidFill>
+            </a:endParaRPr>
+          </a:p>
+          <a:p>
+            <a:pPr marL="171450" indent="-171450">
+              <a:buFont typeface="Arial" panose="020B0604020202020204" pitchFamily="34" charset="0"/>
+              <a:buChar char="•"/>
+            </a:pPr>
+            <a:r>
+              <a:rPr lang="ko-KR" altLang="en-US" sz="1050"/>
+              <a:t>외우는 법</a:t>
+            </a:r>
+            <a:endParaRPr lang="en-US" altLang="ko-KR" sz="1050"/>
+          </a:p>
+          <a:p>
+            <a:r>
+              <a:rPr lang="en-US" altLang="ko-KR" sz="1050"/>
+              <a:t>LettuceConnectionFactory </a:t>
+            </a:r>
+            <a:r>
+              <a:rPr lang="ko-KR" altLang="en-US" sz="1050"/>
+              <a:t>빈을 등록할 때</a:t>
+            </a:r>
+            <a:r>
+              <a:rPr lang="en-US" altLang="ko-KR" sz="1050"/>
+              <a:t>, RedisStandaloneConfiguration</a:t>
+            </a:r>
+            <a:r>
+              <a:rPr lang="ko-KR" altLang="en-US" sz="1050"/>
+              <a:t>을 생성자로 하여 등록했다</a:t>
+            </a:r>
+            <a:r>
+              <a:rPr lang="en-US" altLang="ko-KR" sz="1050"/>
+              <a:t>.</a:t>
+            </a:r>
+          </a:p>
+          <a:p>
+            <a:endParaRPr lang="en-US" altLang="ko-KR" sz="1050"/>
+          </a:p>
+          <a:p>
+            <a:r>
+              <a:rPr lang="ko-KR" altLang="en-US" sz="1050"/>
+              <a:t>동일하게</a:t>
+            </a:r>
+            <a:endParaRPr lang="en-US" altLang="ko-KR" sz="1050"/>
+          </a:p>
+          <a:p>
+            <a:r>
+              <a:rPr lang="en-US" altLang="ko-KR" sz="1050"/>
+              <a:t>RedisConnectionFactory</a:t>
+            </a:r>
+            <a:r>
+              <a:rPr lang="ko-KR" altLang="en-US" sz="1050"/>
+              <a:t>에 </a:t>
+            </a:r>
+            <a:r>
+              <a:rPr lang="en-US" altLang="ko-KR" sz="1050"/>
+              <a:t>RedisCacheConfiguration</a:t>
+            </a:r>
+            <a:r>
+              <a:rPr lang="ko-KR" altLang="en-US" sz="1050"/>
+              <a:t>을 주입하여 </a:t>
+            </a:r>
+            <a:r>
+              <a:rPr lang="en-US" altLang="ko-KR" sz="1050"/>
+              <a:t>CacheManager</a:t>
+            </a:r>
+            <a:r>
+              <a:rPr lang="ko-KR" altLang="en-US" sz="1050"/>
+              <a:t>를 등록한다고 생각하자</a:t>
+            </a:r>
+            <a:r>
+              <a:rPr lang="en-US" altLang="ko-KR" sz="1050"/>
+              <a:t>.</a:t>
+            </a:r>
+          </a:p>
+          <a:p>
+            <a:endParaRPr lang="en-US" altLang="ko-KR" sz="1050"/>
+          </a:p>
+          <a:p>
+            <a:pPr marL="228600" indent="-228600">
+              <a:buAutoNum type="arabicPeriod"/>
+            </a:pPr>
+            <a:r>
+              <a:rPr lang="en-US" altLang="ko-KR" sz="1050"/>
+              <a:t>RedisCacheConfiguration </a:t>
+            </a:r>
+            <a:r>
+              <a:rPr lang="ko-KR" altLang="en-US" sz="1050"/>
+              <a:t>셋팅</a:t>
+            </a:r>
+            <a:endParaRPr lang="en-US" altLang="ko-KR" sz="1050"/>
+          </a:p>
+          <a:p>
+            <a:pPr marL="171450" indent="-171450">
+              <a:buFontTx/>
+              <a:buChar char="-"/>
+            </a:pPr>
+            <a:r>
+              <a:rPr lang="en-US" altLang="ko-KR" sz="1050"/>
+              <a:t>.defaultCacheConfig()   </a:t>
+            </a:r>
+            <a:r>
+              <a:rPr lang="en-US" altLang="ko-KR" sz="1050" b="1">
+                <a:solidFill>
+                  <a:srgbClr val="FF0000"/>
+                </a:solidFill>
+              </a:rPr>
+              <a:t>// </a:t>
+            </a:r>
+            <a:r>
+              <a:rPr lang="ko-KR" altLang="en-US" sz="1050" b="1">
+                <a:solidFill>
+                  <a:srgbClr val="FF0000"/>
+                </a:solidFill>
+              </a:rPr>
+              <a:t>기본 캐시 설정을 진행하겠다</a:t>
+            </a:r>
+            <a:r>
+              <a:rPr lang="en-US" altLang="ko-KR" sz="1050">
+                <a:solidFill>
+                  <a:srgbClr val="FF0000"/>
+                </a:solidFill>
+              </a:rPr>
+              <a:t>.</a:t>
+            </a:r>
+          </a:p>
+          <a:p>
+            <a:pPr marL="171450" indent="-171450">
+              <a:buFontTx/>
+              <a:buChar char="-"/>
+            </a:pPr>
+            <a:r>
+              <a:rPr lang="en-US" altLang="ko-KR" sz="1050"/>
+              <a:t>.serializeKeyWith(    </a:t>
+            </a:r>
+            <a:r>
+              <a:rPr lang="en-US" altLang="ko-KR" sz="1050" b="1">
+                <a:solidFill>
+                  <a:srgbClr val="FF0000"/>
+                </a:solidFill>
+              </a:rPr>
+              <a:t>// </a:t>
+            </a:r>
+            <a:r>
+              <a:rPr lang="ko-KR" altLang="en-US" sz="1050" b="1">
+                <a:solidFill>
+                  <a:srgbClr val="FF0000"/>
+                </a:solidFill>
+              </a:rPr>
+              <a:t>직렬화 </a:t>
+            </a:r>
+            <a:r>
+              <a:rPr lang="en-US" altLang="ko-KR" sz="1050" b="1">
+                <a:solidFill>
+                  <a:srgbClr val="FF0000"/>
+                </a:solidFill>
+              </a:rPr>
+              <a:t>Key </a:t>
+            </a:r>
+            <a:r>
+              <a:rPr lang="ko-KR" altLang="en-US" sz="1050" b="1">
+                <a:solidFill>
+                  <a:srgbClr val="FF0000"/>
+                </a:solidFill>
+              </a:rPr>
+              <a:t>는 다음 객체로 진행</a:t>
+            </a:r>
+            <a:br>
+              <a:rPr lang="en-US" altLang="ko-KR" sz="1050"/>
+            </a:br>
+            <a:r>
+              <a:rPr lang="en-US" altLang="ko-KR" sz="1050"/>
+              <a:t>        RedisSerializationContext.SerializationPair.fromSerializer(</a:t>
+            </a:r>
+            <a:br>
+              <a:rPr lang="en-US" altLang="ko-KR" sz="1050"/>
+            </a:br>
+            <a:r>
+              <a:rPr lang="en-US" altLang="ko-KR" sz="1050"/>
+              <a:t>                new StringRedisSerializer()</a:t>
+            </a:r>
+          </a:p>
+          <a:p>
+            <a:r>
+              <a:rPr lang="en-US" altLang="ko-KR" sz="1050"/>
+              <a:t>              )</a:t>
+            </a:r>
+          </a:p>
+          <a:p>
+            <a:r>
+              <a:rPr lang="en-US" altLang="ko-KR" sz="1050"/>
+              <a:t>      )</a:t>
+            </a:r>
+          </a:p>
+          <a:p>
+            <a:pPr marL="171450" indent="-171450">
+              <a:buFontTx/>
+              <a:buChar char="-"/>
+            </a:pPr>
+            <a:r>
+              <a:rPr lang="en-US" altLang="ko-KR" sz="1050"/>
+              <a:t>.serializeValueWith( </a:t>
+            </a:r>
+            <a:r>
+              <a:rPr lang="en-US" altLang="ko-KR" sz="1050" b="1">
+                <a:solidFill>
+                  <a:srgbClr val="FF0000"/>
+                </a:solidFill>
+              </a:rPr>
+              <a:t>// </a:t>
+            </a:r>
+            <a:r>
+              <a:rPr lang="ko-KR" altLang="en-US" sz="1050" b="1">
+                <a:solidFill>
+                  <a:srgbClr val="FF0000"/>
+                </a:solidFill>
+              </a:rPr>
+              <a:t>직렬화 </a:t>
+            </a:r>
+            <a:r>
+              <a:rPr lang="en-US" altLang="ko-KR" sz="1050" b="1">
+                <a:solidFill>
+                  <a:srgbClr val="FF0000"/>
+                </a:solidFill>
+              </a:rPr>
+              <a:t>Value </a:t>
+            </a:r>
+            <a:r>
+              <a:rPr lang="ko-KR" altLang="en-US" sz="1050" b="1">
+                <a:solidFill>
+                  <a:srgbClr val="FF0000"/>
+                </a:solidFill>
+              </a:rPr>
+              <a:t>는 다음 객체로 진행</a:t>
+            </a:r>
+            <a:br>
+              <a:rPr lang="en-US" altLang="ko-KR" sz="1050" b="1">
+                <a:solidFill>
+                  <a:srgbClr val="FF0000"/>
+                </a:solidFill>
+              </a:rPr>
+            </a:br>
+            <a:r>
+              <a:rPr lang="en-US" altLang="ko-KR" sz="1050"/>
+              <a:t>	RedisSerializationConext.SerializationPair.fromSerializer(</a:t>
+            </a:r>
+            <a:br>
+              <a:rPr lang="en-US" altLang="ko-KR" sz="1050"/>
+            </a:br>
+            <a:r>
+              <a:rPr lang="en-US" altLang="ko-KR" sz="1050"/>
+              <a:t>	       new JacksonJsonRedisSerializer&lt;Object&gt;(Object.class)</a:t>
+            </a:r>
+            <a:br>
+              <a:rPr lang="en-US" altLang="ko-KR" sz="1050"/>
+            </a:br>
+            <a:r>
+              <a:rPr lang="en-US" altLang="ko-KR" sz="1050"/>
+              <a:t>	)</a:t>
+            </a:r>
+            <a:br>
+              <a:rPr lang="en-US" altLang="ko-KR" sz="1050"/>
+            </a:br>
+            <a:r>
+              <a:rPr lang="en-US" altLang="ko-KR" sz="1050"/>
+              <a:t>)</a:t>
+            </a:r>
+            <a:br>
+              <a:rPr lang="en-US" altLang="ko-KR" sz="1050"/>
+            </a:br>
+            <a:r>
+              <a:rPr lang="en-US" altLang="ko-KR" sz="1050"/>
+              <a:t>.entryTtl(Duration.ofMinutes(1L); </a:t>
+            </a:r>
+            <a:r>
+              <a:rPr lang="en-US" altLang="ko-KR" sz="1050" b="1">
+                <a:solidFill>
+                  <a:srgbClr val="FF0000"/>
+                </a:solidFill>
+              </a:rPr>
+              <a:t>// ttl</a:t>
+            </a:r>
+            <a:r>
+              <a:rPr lang="ko-KR" altLang="en-US" sz="1050" b="1">
+                <a:solidFill>
+                  <a:srgbClr val="FF0000"/>
+                </a:solidFill>
+              </a:rPr>
+              <a:t> </a:t>
+            </a:r>
+            <a:r>
+              <a:rPr lang="en-US" altLang="ko-KR" sz="1050" b="1">
+                <a:solidFill>
+                  <a:srgbClr val="FF0000"/>
+                </a:solidFill>
+              </a:rPr>
+              <a:t>1</a:t>
+            </a:r>
+            <a:r>
+              <a:rPr lang="ko-KR" altLang="en-US" sz="1050" b="1">
+                <a:solidFill>
+                  <a:srgbClr val="FF0000"/>
+                </a:solidFill>
+              </a:rPr>
+              <a:t>분 설정</a:t>
+            </a:r>
+            <a:endParaRPr lang="en-US" altLang="ko-KR" sz="1050" b="1">
+              <a:solidFill>
+                <a:srgbClr val="FF0000"/>
+              </a:solidFill>
+            </a:endParaRPr>
+          </a:p>
+          <a:p>
+            <a:endParaRPr lang="en-US" altLang="ko-KR" sz="1050"/>
+          </a:p>
+          <a:p>
+            <a:r>
+              <a:rPr lang="en-US" altLang="ko-KR" sz="1050"/>
+              <a:t>※ RedisSerializationContext.SerializationPair.fromSerializer </a:t>
+            </a:r>
+            <a:br>
+              <a:rPr lang="en-US" altLang="ko-KR" sz="1050"/>
+            </a:br>
+            <a:r>
+              <a:rPr lang="en-US" altLang="ko-KR" sz="1050" b="1">
+                <a:solidFill>
+                  <a:srgbClr val="FF0000"/>
+                </a:solidFill>
+              </a:rPr>
+              <a:t>    </a:t>
+            </a:r>
+            <a:r>
+              <a:rPr lang="ko-KR" altLang="en-US" sz="1050" b="1">
+                <a:solidFill>
+                  <a:srgbClr val="FF0000"/>
+                </a:solidFill>
+              </a:rPr>
+              <a:t>외우자 방법이 없다</a:t>
+            </a:r>
+            <a:r>
+              <a:rPr lang="en-US" altLang="ko-KR" sz="1050" b="1">
+                <a:solidFill>
+                  <a:srgbClr val="FF0000"/>
+                </a:solidFill>
+              </a:rPr>
+              <a:t>. </a:t>
+            </a:r>
+            <a:br>
+              <a:rPr lang="en-US" altLang="ko-KR" sz="1050"/>
+            </a:br>
+            <a:r>
+              <a:rPr lang="en-US" altLang="ko-KR" sz="1050"/>
+              <a:t>※ new StringRedisSerializer() - </a:t>
+            </a:r>
+            <a:r>
+              <a:rPr lang="ko-KR" altLang="en-US" sz="1050" b="1">
+                <a:solidFill>
+                  <a:srgbClr val="FF0000"/>
+                </a:solidFill>
+              </a:rPr>
+              <a:t>외운다 </a:t>
+            </a:r>
+            <a:r>
+              <a:rPr lang="en-US" altLang="ko-KR" sz="1050" b="1">
+                <a:solidFill>
+                  <a:srgbClr val="FF0000"/>
+                </a:solidFill>
+              </a:rPr>
+              <a:t>key </a:t>
+            </a:r>
+            <a:r>
+              <a:rPr lang="ko-KR" altLang="en-US" sz="1050" b="1">
+                <a:solidFill>
+                  <a:srgbClr val="FF0000"/>
+                </a:solidFill>
+              </a:rPr>
+              <a:t>직렬화</a:t>
+            </a:r>
+            <a:endParaRPr lang="en-US" altLang="ko-KR" sz="1050" b="1">
+              <a:solidFill>
+                <a:srgbClr val="FF0000"/>
+              </a:solidFill>
+            </a:endParaRPr>
+          </a:p>
+          <a:p>
+            <a:r>
+              <a:rPr lang="en-US" altLang="ko-KR" sz="1050"/>
+              <a:t>※ JacksonJsonRedisSerializer&lt;Object&gt;(Object.class) - </a:t>
+            </a:r>
+            <a:r>
+              <a:rPr lang="ko-KR" altLang="en-US" sz="1050" b="1">
+                <a:solidFill>
+                  <a:srgbClr val="FF0000"/>
+                </a:solidFill>
+              </a:rPr>
+              <a:t>닥치고 외워라</a:t>
+            </a:r>
+            <a:endParaRPr lang="en-US" altLang="ko-KR" sz="1050" b="1">
+              <a:solidFill>
+                <a:srgbClr val="FF0000"/>
+              </a:solidFill>
+            </a:endParaRPr>
+          </a:p>
+        </p:txBody>
+      </p:sp>
+    </p:spTree>
+    <p:extLst>
+      <p:ext uri="{BB962C8B-B14F-4D97-AF65-F5344CB8AC3E}">
+        <p14:creationId xmlns:p14="http://schemas.microsoft.com/office/powerpoint/2010/main" val="4218188269"/>
+      </p:ext>
+    </p:extLst>
+  </p:cSld>
+  <p:clrMapOvr>
+    <a:masterClrMapping/>
+  </p:clrMapOvr>
+</p:sld>
+</file>
+
+<file path=ppt/slides/slide14.xml><?xml version="1.0" encoding="utf-8"?>
+<p:sld xmlns:a="http://schemas.openxmlformats.org/drawingml/2006/main" xmlns:r="http://schemas.openxmlformats.org/officeDocument/2006/relationships" xmlns:p="http://schemas.openxmlformats.org/presentationml/2006/main">
+  <p:cSld>
+    <p:spTree>
+      <p:nvGrpSpPr>
+        <p:cNvPr id="1" name=""/>
+        <p:cNvGrpSpPr/>
+        <p:nvPr/>
+      </p:nvGrpSpPr>
+      <p:grpSpPr>
+        <a:xfrm>
+          <a:off x="0" y="0"/>
+          <a:ext cx="0" cy="0"/>
+          <a:chOff x="0" y="0"/>
+          <a:chExt cx="0" cy="0"/>
+        </a:xfrm>
+      </p:grpSpPr>
+      <p:sp>
+        <p:nvSpPr>
+          <p:cNvPr id="2" name="제목 1">
+            <a:extLst>
+              <a:ext uri="{FF2B5EF4-FFF2-40B4-BE49-F238E27FC236}">
+                <a16:creationId xmlns:a16="http://schemas.microsoft.com/office/drawing/2014/main" id="{219A2F51-96FB-7EAC-0F72-527FAA0EDB08}"/>
+              </a:ext>
+            </a:extLst>
+          </p:cNvPr>
+          <p:cNvSpPr>
+            <a:spLocks noGrp="1"/>
+          </p:cNvSpPr>
+          <p:nvPr>
+            <p:ph type="title"/>
+          </p:nvPr>
+        </p:nvSpPr>
+        <p:spPr/>
+        <p:txBody>
+          <a:bodyPr>
+            <a:normAutofit/>
+          </a:bodyPr>
+          <a:lstStyle/>
+          <a:p>
+            <a:r>
+              <a:rPr lang="ko-KR" altLang="en-US" sz="4000"/>
+              <a:t>조회 서비스 메소드에 </a:t>
+            </a:r>
+            <a:r>
+              <a:rPr lang="en-US" altLang="ko-KR" sz="4000"/>
+              <a:t>Redis</a:t>
+            </a:r>
+            <a:r>
+              <a:rPr lang="ko-KR" altLang="en-US" sz="4000"/>
+              <a:t>캐시 적용</a:t>
+            </a:r>
+          </a:p>
+        </p:txBody>
+      </p:sp>
+      <p:grpSp>
+        <p:nvGrpSpPr>
+          <p:cNvPr id="17" name="그룹 16">
+            <a:extLst>
+              <a:ext uri="{FF2B5EF4-FFF2-40B4-BE49-F238E27FC236}">
+                <a16:creationId xmlns:a16="http://schemas.microsoft.com/office/drawing/2014/main" id="{0AF885DD-EA27-1B79-572B-A7BE5398856A}"/>
+              </a:ext>
+            </a:extLst>
+          </p:cNvPr>
+          <p:cNvGrpSpPr/>
+          <p:nvPr/>
+        </p:nvGrpSpPr>
+        <p:grpSpPr>
+          <a:xfrm>
+            <a:off x="903544" y="2358776"/>
+            <a:ext cx="10808266" cy="3876547"/>
+            <a:chOff x="903544" y="2358776"/>
+            <a:chExt cx="10808266" cy="3876547"/>
+          </a:xfrm>
+        </p:grpSpPr>
+        <p:grpSp>
+          <p:nvGrpSpPr>
+            <p:cNvPr id="8" name="그룹 7">
+              <a:extLst>
+                <a:ext uri="{FF2B5EF4-FFF2-40B4-BE49-F238E27FC236}">
+                  <a16:creationId xmlns:a16="http://schemas.microsoft.com/office/drawing/2014/main" id="{04024BBA-02F6-D0B1-0666-98757430DBAE}"/>
+                </a:ext>
+              </a:extLst>
+            </p:cNvPr>
+            <p:cNvGrpSpPr/>
+            <p:nvPr/>
+          </p:nvGrpSpPr>
+          <p:grpSpPr>
+            <a:xfrm>
+              <a:off x="903544" y="2377058"/>
+              <a:ext cx="2534004" cy="2743583"/>
+              <a:chOff x="903544" y="2377058"/>
+              <a:chExt cx="2534004" cy="2743583"/>
+            </a:xfrm>
+          </p:grpSpPr>
+          <p:pic>
+            <p:nvPicPr>
+              <p:cNvPr id="6" name="그림 5">
+                <a:extLst>
+                  <a:ext uri="{FF2B5EF4-FFF2-40B4-BE49-F238E27FC236}">
+                    <a16:creationId xmlns:a16="http://schemas.microsoft.com/office/drawing/2014/main" id="{31EE4594-266B-FCB9-FA49-764144B30544}"/>
+                  </a:ext>
+                </a:extLst>
+              </p:cNvPr>
+              <p:cNvPicPr>
+                <a:picLocks noChangeAspect="1"/>
+              </p:cNvPicPr>
+              <p:nvPr/>
+            </p:nvPicPr>
+            <p:blipFill>
+              <a:blip r:embed="rId2"/>
+              <a:stretch>
+                <a:fillRect/>
+              </a:stretch>
+            </p:blipFill>
+            <p:spPr>
+              <a:xfrm>
+                <a:off x="903544" y="2377058"/>
+                <a:ext cx="2534004" cy="2743583"/>
+              </a:xfrm>
+              <a:prstGeom prst="rect">
+                <a:avLst/>
+              </a:prstGeom>
+            </p:spPr>
+          </p:pic>
+          <p:sp>
+            <p:nvSpPr>
+              <p:cNvPr id="7" name="직사각형 6">
+                <a:extLst>
+                  <a:ext uri="{FF2B5EF4-FFF2-40B4-BE49-F238E27FC236}">
+                    <a16:creationId xmlns:a16="http://schemas.microsoft.com/office/drawing/2014/main" id="{CE0C08A9-DF5F-7358-8D06-229F8602E9E1}"/>
+                  </a:ext>
+                </a:extLst>
+              </p:cNvPr>
+              <p:cNvSpPr/>
+              <p:nvPr/>
+            </p:nvSpPr>
+            <p:spPr>
+              <a:xfrm>
+                <a:off x="1256145" y="4248727"/>
+                <a:ext cx="1320800" cy="267855"/>
+              </a:xfrm>
+              <a:prstGeom prst="rect">
+                <a:avLst/>
+              </a:prstGeom>
+              <a:noFill/>
+              <a:ln>
+                <a:solidFill>
+                  <a:srgbClr val="FF0000"/>
+                </a:solidFill>
+              </a:ln>
+            </p:spPr>
+            <p:style>
+              <a:lnRef idx="2">
+                <a:schemeClr val="accent1">
+                  <a:shade val="15000"/>
+                </a:schemeClr>
+              </a:lnRef>
+              <a:fillRef idx="1">
+                <a:schemeClr val="accent1"/>
+              </a:fillRef>
+              <a:effectRef idx="0">
+                <a:schemeClr val="accent1"/>
+              </a:effectRef>
+              <a:fontRef idx="minor">
+                <a:schemeClr val="lt1"/>
+              </a:fontRef>
+            </p:style>
+            <p:txBody>
+              <a:bodyPr rtlCol="0" anchor="ctr"/>
+              <a:lstStyle/>
+              <a:p>
+                <a:pPr algn="ctr"/>
+                <a:endParaRPr lang="ko-KR" altLang="en-US"/>
+              </a:p>
+            </p:txBody>
+          </p:sp>
+        </p:grpSp>
+        <p:grpSp>
+          <p:nvGrpSpPr>
+            <p:cNvPr id="10" name="그룹 9">
+              <a:extLst>
+                <a:ext uri="{FF2B5EF4-FFF2-40B4-BE49-F238E27FC236}">
+                  <a16:creationId xmlns:a16="http://schemas.microsoft.com/office/drawing/2014/main" id="{6FC9B9D6-F958-919C-1B83-9583FDE0644E}"/>
+                </a:ext>
+              </a:extLst>
+            </p:cNvPr>
+            <p:cNvGrpSpPr/>
+            <p:nvPr/>
+          </p:nvGrpSpPr>
+          <p:grpSpPr>
+            <a:xfrm>
+              <a:off x="3660538" y="2358776"/>
+              <a:ext cx="8051272" cy="2952133"/>
+              <a:chOff x="3660538" y="2358776"/>
+              <a:chExt cx="8051272" cy="2952133"/>
+            </a:xfrm>
+          </p:grpSpPr>
+          <p:pic>
+            <p:nvPicPr>
+              <p:cNvPr id="4" name="그림 3">
+                <a:extLst>
+                  <a:ext uri="{FF2B5EF4-FFF2-40B4-BE49-F238E27FC236}">
+                    <a16:creationId xmlns:a16="http://schemas.microsoft.com/office/drawing/2014/main" id="{BF6E7A11-7793-3156-9B6B-C93C7537A48A}"/>
+                  </a:ext>
+                </a:extLst>
+              </p:cNvPr>
+              <p:cNvPicPr>
+                <a:picLocks noChangeAspect="1"/>
+              </p:cNvPicPr>
+              <p:nvPr/>
+            </p:nvPicPr>
+            <p:blipFill>
+              <a:blip r:embed="rId3"/>
+              <a:stretch>
+                <a:fillRect/>
+              </a:stretch>
+            </p:blipFill>
+            <p:spPr>
+              <a:xfrm>
+                <a:off x="3660538" y="2358776"/>
+                <a:ext cx="8051272" cy="2952133"/>
+              </a:xfrm>
+              <a:prstGeom prst="rect">
+                <a:avLst/>
+              </a:prstGeom>
+            </p:spPr>
+          </p:pic>
+          <p:sp>
+            <p:nvSpPr>
+              <p:cNvPr id="9" name="직사각형 8">
+                <a:extLst>
+                  <a:ext uri="{FF2B5EF4-FFF2-40B4-BE49-F238E27FC236}">
+                    <a16:creationId xmlns:a16="http://schemas.microsoft.com/office/drawing/2014/main" id="{2261A6BA-5415-A583-8AF9-60DB7A6D0469}"/>
+                  </a:ext>
+                </a:extLst>
+              </p:cNvPr>
+              <p:cNvSpPr/>
+              <p:nvPr/>
+            </p:nvSpPr>
+            <p:spPr>
+              <a:xfrm>
+                <a:off x="10495280" y="3700914"/>
+                <a:ext cx="1216530" cy="267855"/>
+              </a:xfrm>
+              <a:prstGeom prst="rect">
+                <a:avLst/>
+              </a:prstGeom>
+              <a:noFill/>
+              <a:ln>
+                <a:solidFill>
+                  <a:srgbClr val="FF0000"/>
+                </a:solidFill>
+              </a:ln>
+            </p:spPr>
+            <p:style>
+              <a:lnRef idx="2">
+                <a:schemeClr val="accent1">
+                  <a:shade val="15000"/>
+                </a:schemeClr>
+              </a:lnRef>
+              <a:fillRef idx="1">
+                <a:schemeClr val="accent1"/>
+              </a:fillRef>
+              <a:effectRef idx="0">
+                <a:schemeClr val="accent1"/>
+              </a:effectRef>
+              <a:fontRef idx="minor">
+                <a:schemeClr val="lt1"/>
+              </a:fontRef>
+            </p:style>
+            <p:txBody>
+              <a:bodyPr rtlCol="0" anchor="ctr"/>
+              <a:lstStyle/>
+              <a:p>
+                <a:pPr algn="ctr"/>
+                <a:endParaRPr lang="ko-KR" altLang="en-US"/>
+              </a:p>
+            </p:txBody>
+          </p:sp>
+        </p:grpSp>
+        <p:grpSp>
+          <p:nvGrpSpPr>
+            <p:cNvPr id="14" name="그룹 13">
+              <a:extLst>
+                <a:ext uri="{FF2B5EF4-FFF2-40B4-BE49-F238E27FC236}">
+                  <a16:creationId xmlns:a16="http://schemas.microsoft.com/office/drawing/2014/main" id="{88FE63D0-AC32-997D-7BF8-39E66BA29468}"/>
+                </a:ext>
+              </a:extLst>
+            </p:cNvPr>
+            <p:cNvGrpSpPr/>
+            <p:nvPr/>
+          </p:nvGrpSpPr>
+          <p:grpSpPr>
+            <a:xfrm>
+              <a:off x="3702029" y="5425585"/>
+              <a:ext cx="4848902" cy="809738"/>
+              <a:chOff x="3702029" y="5425585"/>
+              <a:chExt cx="4848902" cy="809738"/>
+            </a:xfrm>
+          </p:grpSpPr>
+          <p:pic>
+            <p:nvPicPr>
+              <p:cNvPr id="12" name="그림 11">
+                <a:extLst>
+                  <a:ext uri="{FF2B5EF4-FFF2-40B4-BE49-F238E27FC236}">
+                    <a16:creationId xmlns:a16="http://schemas.microsoft.com/office/drawing/2014/main" id="{88BC0AAB-640C-6F8B-24CA-52C9EA5B3F65}"/>
+                  </a:ext>
+                </a:extLst>
+              </p:cNvPr>
+              <p:cNvPicPr>
+                <a:picLocks noChangeAspect="1"/>
+              </p:cNvPicPr>
+              <p:nvPr/>
+            </p:nvPicPr>
+            <p:blipFill>
+              <a:blip r:embed="rId4"/>
+              <a:stretch>
+                <a:fillRect/>
+              </a:stretch>
+            </p:blipFill>
+            <p:spPr>
+              <a:xfrm>
+                <a:off x="3702029" y="5425585"/>
+                <a:ext cx="4848902" cy="809738"/>
+              </a:xfrm>
+              <a:prstGeom prst="rect">
+                <a:avLst/>
+              </a:prstGeom>
+            </p:spPr>
+          </p:pic>
+          <p:sp>
+            <p:nvSpPr>
+              <p:cNvPr id="13" name="직사각형 12">
+                <a:extLst>
+                  <a:ext uri="{FF2B5EF4-FFF2-40B4-BE49-F238E27FC236}">
+                    <a16:creationId xmlns:a16="http://schemas.microsoft.com/office/drawing/2014/main" id="{83A4BDC7-02E5-4643-BED8-908F3B467295}"/>
+                  </a:ext>
+                </a:extLst>
+              </p:cNvPr>
+              <p:cNvSpPr/>
+              <p:nvPr/>
+            </p:nvSpPr>
+            <p:spPr>
+              <a:xfrm>
+                <a:off x="5144654" y="5932325"/>
+                <a:ext cx="951345" cy="165984"/>
+              </a:xfrm>
+              <a:prstGeom prst="rect">
+                <a:avLst/>
+              </a:prstGeom>
+              <a:noFill/>
+              <a:ln>
+                <a:solidFill>
+                  <a:srgbClr val="FF0000"/>
+                </a:solidFill>
+              </a:ln>
+            </p:spPr>
+            <p:style>
+              <a:lnRef idx="2">
+                <a:schemeClr val="accent1">
+                  <a:shade val="15000"/>
+                </a:schemeClr>
+              </a:lnRef>
+              <a:fillRef idx="1">
+                <a:schemeClr val="accent1"/>
+              </a:fillRef>
+              <a:effectRef idx="0">
+                <a:schemeClr val="accent1"/>
+              </a:effectRef>
+              <a:fontRef idx="minor">
+                <a:schemeClr val="lt1"/>
+              </a:fontRef>
+            </p:style>
+            <p:txBody>
+              <a:bodyPr rtlCol="0" anchor="ctr"/>
+              <a:lstStyle/>
+              <a:p>
+                <a:pPr algn="ctr"/>
+                <a:endParaRPr lang="ko-KR" altLang="en-US"/>
+              </a:p>
+            </p:txBody>
+          </p:sp>
+        </p:grpSp>
+        <p:cxnSp>
+          <p:nvCxnSpPr>
+            <p:cNvPr id="16" name="직선 화살표 연결선 15">
+              <a:extLst>
+                <a:ext uri="{FF2B5EF4-FFF2-40B4-BE49-F238E27FC236}">
+                  <a16:creationId xmlns:a16="http://schemas.microsoft.com/office/drawing/2014/main" id="{F01D7D86-7956-850B-B13D-9C647AB47084}"/>
+                </a:ext>
+              </a:extLst>
+            </p:cNvPr>
+            <p:cNvCxnSpPr>
+              <a:stCxn id="9" idx="2"/>
+              <a:endCxn id="13" idx="0"/>
+            </p:cNvCxnSpPr>
+            <p:nvPr/>
+          </p:nvCxnSpPr>
+          <p:spPr>
+            <a:xfrm flipH="1">
+              <a:off x="5620327" y="3968769"/>
+              <a:ext cx="5483218" cy="1963556"/>
+            </a:xfrm>
+            <a:prstGeom prst="straightConnector1">
+              <a:avLst/>
+            </a:prstGeom>
+            <a:ln>
+              <a:solidFill>
+                <a:srgbClr val="FF0000"/>
+              </a:solidFill>
+              <a:tailEnd type="triangle"/>
+            </a:ln>
+          </p:spPr>
+          <p:style>
+            <a:lnRef idx="1">
+              <a:schemeClr val="accent1"/>
+            </a:lnRef>
+            <a:fillRef idx="0">
+              <a:schemeClr val="accent1"/>
+            </a:fillRef>
+            <a:effectRef idx="0">
+              <a:schemeClr val="accent1"/>
+            </a:effectRef>
+            <a:fontRef idx="minor">
+              <a:schemeClr val="tx1"/>
+            </a:fontRef>
+          </p:style>
+        </p:cxnSp>
+      </p:grpSp>
+    </p:spTree>
+    <p:extLst>
+      <p:ext uri="{BB962C8B-B14F-4D97-AF65-F5344CB8AC3E}">
+        <p14:creationId xmlns:p14="http://schemas.microsoft.com/office/powerpoint/2010/main" val="239200790"/>
+      </p:ext>
+    </p:extLst>
+  </p:cSld>
+  <p:clrMapOvr>
+    <a:masterClrMapping/>
+  </p:clrMapOvr>
+</p:sld>
+</file>
+
+<file path=ppt/slides/slide15.xml><?xml version="1.0" encoding="utf-8"?>
+<p:sld xmlns:a="http://schemas.openxmlformats.org/drawingml/2006/main" xmlns:r="http://schemas.openxmlformats.org/officeDocument/2006/relationships" xmlns:p="http://schemas.openxmlformats.org/presentationml/2006/main">
+  <p:cSld>
+    <p:spTree>
+      <p:nvGrpSpPr>
+        <p:cNvPr id="1" name=""/>
+        <p:cNvGrpSpPr/>
+        <p:nvPr/>
+      </p:nvGrpSpPr>
+      <p:grpSpPr>
+        <a:xfrm>
+          <a:off x="0" y="0"/>
+          <a:ext cx="0" cy="0"/>
+          <a:chOff x="0" y="0"/>
+          <a:chExt cx="0" cy="0"/>
+        </a:xfrm>
+      </p:grpSpPr>
+      <p:sp>
+        <p:nvSpPr>
+          <p:cNvPr id="2" name="제목 1">
+            <a:extLst>
+              <a:ext uri="{FF2B5EF4-FFF2-40B4-BE49-F238E27FC236}">
+                <a16:creationId xmlns:a16="http://schemas.microsoft.com/office/drawing/2014/main" id="{86C2347B-0E38-E7CA-DA06-6398BE8D0828}"/>
+              </a:ext>
+            </a:extLst>
+          </p:cNvPr>
+          <p:cNvSpPr>
+            <a:spLocks noGrp="1"/>
+          </p:cNvSpPr>
+          <p:nvPr>
+            <p:ph type="title"/>
+          </p:nvPr>
+        </p:nvSpPr>
+        <p:spPr/>
+        <p:txBody>
+          <a:bodyPr>
+            <a:normAutofit/>
+          </a:bodyPr>
+          <a:lstStyle/>
+          <a:p>
+            <a:r>
+              <a:rPr lang="en-US" altLang="ko-KR" sz="2800"/>
+              <a:t>BoardService</a:t>
+            </a:r>
+            <a:r>
+              <a:rPr lang="ko-KR" altLang="en-US" sz="2800"/>
+              <a:t>에 </a:t>
+            </a:r>
+            <a:r>
+              <a:rPr lang="en-US" altLang="ko-KR" sz="2800"/>
+              <a:t>Cache</a:t>
+            </a:r>
+            <a:r>
+              <a:rPr lang="ko-KR" altLang="en-US" sz="2800"/>
+              <a:t>를 적용할 메소드에 </a:t>
+            </a:r>
+            <a:r>
+              <a:rPr lang="en-US" altLang="ko-KR" sz="2800"/>
+              <a:t>@Cacheable </a:t>
+            </a:r>
+            <a:r>
+              <a:rPr lang="ko-KR" altLang="en-US" sz="2800"/>
+              <a:t>적용</a:t>
+            </a:r>
+          </a:p>
+        </p:txBody>
+      </p:sp>
+      <p:pic>
+        <p:nvPicPr>
+          <p:cNvPr id="4" name="그림 3">
+            <a:extLst>
+              <a:ext uri="{FF2B5EF4-FFF2-40B4-BE49-F238E27FC236}">
+                <a16:creationId xmlns:a16="http://schemas.microsoft.com/office/drawing/2014/main" id="{E6D30D94-8AAD-A25E-8D0C-A2100B0964AB}"/>
+              </a:ext>
+            </a:extLst>
+          </p:cNvPr>
+          <p:cNvPicPr>
+            <a:picLocks noChangeAspect="1"/>
+          </p:cNvPicPr>
+          <p:nvPr/>
+        </p:nvPicPr>
+        <p:blipFill>
+          <a:blip r:embed="rId2"/>
+          <a:stretch>
+            <a:fillRect/>
+          </a:stretch>
+        </p:blipFill>
+        <p:spPr>
+          <a:xfrm>
+            <a:off x="1097280" y="1807075"/>
+            <a:ext cx="9164320" cy="3243850"/>
+          </a:xfrm>
+          <a:prstGeom prst="rect">
+            <a:avLst/>
+          </a:prstGeom>
+        </p:spPr>
+      </p:pic>
+    </p:spTree>
+    <p:extLst>
+      <p:ext uri="{BB962C8B-B14F-4D97-AF65-F5344CB8AC3E}">
+        <p14:creationId xmlns:p14="http://schemas.microsoft.com/office/powerpoint/2010/main" val="3366824173"/>
+      </p:ext>
+    </p:extLst>
+  </p:cSld>
+  <p:clrMapOvr>
+    <a:masterClrMapping/>
+  </p:clrMapOvr>
+</p:sld>
+</file>
+
+<file path=ppt/slides/slide16.xml><?xml version="1.0" encoding="utf-8"?>
+<p:sld xmlns:a="http://schemas.openxmlformats.org/drawingml/2006/main" xmlns:r="http://schemas.openxmlformats.org/officeDocument/2006/relationships" xmlns:p="http://schemas.openxmlformats.org/presentationml/2006/main">
+  <p:cSld>
+    <p:spTree>
+      <p:nvGrpSpPr>
+        <p:cNvPr id="1" name=""/>
+        <p:cNvGrpSpPr/>
+        <p:nvPr/>
+      </p:nvGrpSpPr>
+      <p:grpSpPr>
+        <a:xfrm>
+          <a:off x="0" y="0"/>
+          <a:ext cx="0" cy="0"/>
+          <a:chOff x="0" y="0"/>
+          <a:chExt cx="0" cy="0"/>
+        </a:xfrm>
+      </p:grpSpPr>
+      <p:sp>
+        <p:nvSpPr>
+          <p:cNvPr id="2" name="제목 1">
+            <a:extLst>
+              <a:ext uri="{FF2B5EF4-FFF2-40B4-BE49-F238E27FC236}">
+                <a16:creationId xmlns:a16="http://schemas.microsoft.com/office/drawing/2014/main" id="{B6276E27-E2EB-7E53-6942-A5D47F15B4EC}"/>
+              </a:ext>
+            </a:extLst>
+          </p:cNvPr>
+          <p:cNvSpPr>
+            <a:spLocks noGrp="1"/>
+          </p:cNvSpPr>
+          <p:nvPr>
+            <p:ph type="title"/>
+          </p:nvPr>
+        </p:nvSpPr>
+        <p:spPr/>
+        <p:txBody>
+          <a:bodyPr/>
+          <a:lstStyle/>
+          <a:p>
+            <a:r>
+              <a:rPr lang="ko-KR" altLang="en-US"/>
+              <a:t>캐시미적용</a:t>
+            </a:r>
+          </a:p>
+        </p:txBody>
+      </p:sp>
+      <p:grpSp>
+        <p:nvGrpSpPr>
+          <p:cNvPr id="6" name="그룹 5">
+            <a:extLst>
+              <a:ext uri="{FF2B5EF4-FFF2-40B4-BE49-F238E27FC236}">
+                <a16:creationId xmlns:a16="http://schemas.microsoft.com/office/drawing/2014/main" id="{973F804B-2F37-8812-199F-B43561C11B58}"/>
+              </a:ext>
+            </a:extLst>
+          </p:cNvPr>
+          <p:cNvGrpSpPr/>
+          <p:nvPr/>
+        </p:nvGrpSpPr>
+        <p:grpSpPr>
+          <a:xfrm>
+            <a:off x="206826" y="1874592"/>
+            <a:ext cx="6997538" cy="2440540"/>
+            <a:chOff x="206826" y="1874592"/>
+            <a:chExt cx="6997538" cy="2440540"/>
+          </a:xfrm>
+        </p:grpSpPr>
+        <p:pic>
+          <p:nvPicPr>
+            <p:cNvPr id="4" name="그림 3">
+              <a:extLst>
+                <a:ext uri="{FF2B5EF4-FFF2-40B4-BE49-F238E27FC236}">
+                  <a16:creationId xmlns:a16="http://schemas.microsoft.com/office/drawing/2014/main" id="{96D36584-3E95-AB6C-8E0E-9DAA2B5E5076}"/>
+                </a:ext>
+              </a:extLst>
+            </p:cNvPr>
+            <p:cNvPicPr>
+              <a:picLocks noChangeAspect="1"/>
+            </p:cNvPicPr>
+            <p:nvPr/>
+          </p:nvPicPr>
+          <p:blipFill>
+            <a:blip r:embed="rId2"/>
+            <a:stretch>
+              <a:fillRect/>
+            </a:stretch>
+          </p:blipFill>
+          <p:spPr>
+            <a:xfrm>
+              <a:off x="206826" y="1874592"/>
+              <a:ext cx="6997538" cy="2440540"/>
+            </a:xfrm>
+            <a:prstGeom prst="rect">
+              <a:avLst/>
+            </a:prstGeom>
+          </p:spPr>
+        </p:pic>
+        <p:sp>
+          <p:nvSpPr>
+            <p:cNvPr id="5" name="직사각형 4">
+              <a:extLst>
+                <a:ext uri="{FF2B5EF4-FFF2-40B4-BE49-F238E27FC236}">
+                  <a16:creationId xmlns:a16="http://schemas.microsoft.com/office/drawing/2014/main" id="{81CAA412-9652-4A1E-4E05-9CD26C554788}"/>
+                </a:ext>
+              </a:extLst>
+            </p:cNvPr>
+            <p:cNvSpPr/>
+            <p:nvPr/>
+          </p:nvSpPr>
+          <p:spPr>
+            <a:xfrm>
+              <a:off x="683491" y="3011055"/>
+              <a:ext cx="6520873" cy="175490"/>
+            </a:xfrm>
+            <a:prstGeom prst="rect">
+              <a:avLst/>
+            </a:prstGeom>
+            <a:noFill/>
+            <a:ln>
+              <a:solidFill>
+                <a:srgbClr val="FF0000"/>
+              </a:solidFill>
+            </a:ln>
+          </p:spPr>
+          <p:style>
+            <a:lnRef idx="2">
+              <a:schemeClr val="accent1">
+                <a:shade val="15000"/>
+              </a:schemeClr>
+            </a:lnRef>
+            <a:fillRef idx="1">
+              <a:schemeClr val="accent1"/>
+            </a:fillRef>
+            <a:effectRef idx="0">
+              <a:schemeClr val="accent1"/>
+            </a:effectRef>
+            <a:fontRef idx="minor">
+              <a:schemeClr val="lt1"/>
+            </a:fontRef>
+          </p:style>
+          <p:txBody>
+            <a:bodyPr rtlCol="0" anchor="ctr"/>
+            <a:lstStyle/>
+            <a:p>
+              <a:pPr algn="ctr"/>
+              <a:endParaRPr lang="ko-KR" altLang="en-US"/>
+            </a:p>
+          </p:txBody>
+        </p:sp>
+      </p:grpSp>
+      <p:sp>
+        <p:nvSpPr>
+          <p:cNvPr id="7" name="TextBox 6">
+            <a:extLst>
+              <a:ext uri="{FF2B5EF4-FFF2-40B4-BE49-F238E27FC236}">
+                <a16:creationId xmlns:a16="http://schemas.microsoft.com/office/drawing/2014/main" id="{8C19F9BF-5839-6675-253A-33D62F01EAFF}"/>
+              </a:ext>
+            </a:extLst>
+          </p:cNvPr>
+          <p:cNvSpPr txBox="1"/>
+          <p:nvPr/>
+        </p:nvSpPr>
+        <p:spPr>
+          <a:xfrm>
+            <a:off x="206826" y="4414982"/>
+            <a:ext cx="6997538" cy="1754326"/>
+          </a:xfrm>
+          <a:prstGeom prst="rect">
+            <a:avLst/>
+          </a:prstGeom>
+          <a:noFill/>
+        </p:spPr>
+        <p:txBody>
+          <a:bodyPr wrap="square" rtlCol="0">
+            <a:spAutoFit/>
+          </a:bodyPr>
+          <a:lstStyle/>
+          <a:p>
+            <a:r>
+              <a:rPr lang="en-US" altLang="ko-KR" sz="1200"/>
+              <a:t>1. </a:t>
+            </a:r>
+            <a:r>
+              <a:rPr lang="ko-KR" altLang="en-US" sz="1200"/>
+              <a:t>캐시를 적용하는 서비스 메소드에서 </a:t>
+            </a:r>
+            <a:r>
+              <a:rPr lang="en-US" altLang="ko-KR" sz="1200"/>
+              <a:t>@Cacheable </a:t>
+            </a:r>
+            <a:r>
+              <a:rPr lang="ko-KR" altLang="en-US" sz="1200"/>
+              <a:t>애노테이션을 주석처리</a:t>
+            </a:r>
+            <a:endParaRPr lang="en-US" altLang="ko-KR" sz="1200"/>
+          </a:p>
+          <a:p>
+            <a:r>
+              <a:rPr lang="en-US" altLang="ko-KR" sz="1200"/>
+              <a:t>2. /boards</a:t>
+            </a:r>
+            <a:r>
+              <a:rPr lang="ko-KR" altLang="en-US" sz="1200"/>
+              <a:t> 로 </a:t>
+            </a:r>
+            <a:r>
+              <a:rPr lang="en-US" altLang="ko-KR" sz="1200"/>
+              <a:t>Get </a:t>
+            </a:r>
+            <a:r>
+              <a:rPr lang="ko-KR" altLang="en-US" sz="1200"/>
+              <a:t>요청 </a:t>
+            </a:r>
+            <a:endParaRPr lang="en-US" altLang="ko-KR" sz="1200"/>
+          </a:p>
+          <a:p>
+            <a:r>
+              <a:rPr lang="en-US" altLang="ko-KR" sz="1200"/>
+              <a:t>3. </a:t>
+            </a:r>
+            <a:r>
+              <a:rPr lang="ko-KR" altLang="en-US" sz="1200"/>
+              <a:t>요청 시간 측정 </a:t>
+            </a:r>
+            <a:r>
+              <a:rPr lang="en-US" altLang="ko-KR" sz="1200"/>
+              <a:t>( 2~3</a:t>
+            </a:r>
+            <a:r>
+              <a:rPr lang="ko-KR" altLang="en-US" sz="1200"/>
+              <a:t>번 반복</a:t>
+            </a:r>
+            <a:r>
+              <a:rPr lang="en-US" altLang="ko-KR" sz="1200"/>
+              <a:t>)</a:t>
+            </a:r>
+          </a:p>
+          <a:p>
+            <a:endParaRPr lang="en-US" altLang="ko-KR" sz="1200"/>
+          </a:p>
+          <a:p>
+            <a:r>
+              <a:rPr lang="ko-KR" altLang="en-US" sz="1200"/>
+              <a:t>첫 요청시 </a:t>
+            </a:r>
+            <a:r>
+              <a:rPr lang="en-US" altLang="ko-KR" sz="1200"/>
+              <a:t>JPA </a:t>
+            </a:r>
+            <a:r>
+              <a:rPr lang="ko-KR" altLang="en-US" sz="1200"/>
+              <a:t>또한 내부적으로 영속성 컨텍스트를 사용함으로써</a:t>
+            </a:r>
+            <a:r>
+              <a:rPr lang="en-US" altLang="ko-KR" sz="1200"/>
+              <a:t>, </a:t>
+            </a:r>
+            <a:r>
+              <a:rPr lang="ko-KR" altLang="en-US" sz="1200"/>
+              <a:t>데이터가 없을시</a:t>
+            </a:r>
+            <a:br>
+              <a:rPr lang="en-US" altLang="ko-KR" sz="1200"/>
+            </a:br>
+            <a:r>
+              <a:rPr lang="en-US" altLang="ko-KR" sz="1200"/>
+              <a:t>DB</a:t>
+            </a:r>
+            <a:r>
+              <a:rPr lang="ko-KR" altLang="en-US" sz="1200"/>
+              <a:t>조회 후 영속성 컨텍스트에 엔티티 등록</a:t>
+            </a:r>
+            <a:r>
+              <a:rPr lang="en-US" altLang="ko-KR" sz="1200"/>
+              <a:t>. </a:t>
+            </a:r>
+            <a:r>
+              <a:rPr lang="ko-KR" altLang="en-US" sz="1200"/>
+              <a:t>이후 같은 쿼리는 영속성 컨텍스트 내 캐시를 반환함으로 속도가 빨라진다</a:t>
+            </a:r>
+            <a:r>
+              <a:rPr lang="en-US" altLang="ko-KR" sz="1200"/>
+              <a:t>.</a:t>
+            </a:r>
+          </a:p>
+          <a:p>
+            <a:endParaRPr lang="en-US" altLang="ko-KR" sz="1200"/>
+          </a:p>
+          <a:p>
+            <a:r>
+              <a:rPr lang="ko-KR" altLang="en-US" sz="1200"/>
+              <a:t>그러나 응답시간이 </a:t>
+            </a:r>
+            <a:r>
+              <a:rPr lang="en-US" altLang="ko-KR" sz="1200"/>
+              <a:t>120ms </a:t>
+            </a:r>
+            <a:r>
+              <a:rPr lang="ko-KR" altLang="en-US" sz="1200"/>
+              <a:t>이하으로는 빨라지지 않는것을 확인할 수 있다</a:t>
+            </a:r>
+            <a:r>
+              <a:rPr lang="en-US" altLang="ko-KR" sz="1200"/>
+              <a:t>.</a:t>
+            </a:r>
+            <a:endParaRPr lang="ko-KR" altLang="en-US" sz="1200"/>
+          </a:p>
+        </p:txBody>
+      </p:sp>
+      <p:pic>
+        <p:nvPicPr>
+          <p:cNvPr id="11" name="그림 10">
+            <a:extLst>
+              <a:ext uri="{FF2B5EF4-FFF2-40B4-BE49-F238E27FC236}">
+                <a16:creationId xmlns:a16="http://schemas.microsoft.com/office/drawing/2014/main" id="{0126E190-9B7E-BCE1-C606-DD953BE87258}"/>
+              </a:ext>
+            </a:extLst>
+          </p:cNvPr>
+          <p:cNvPicPr>
+            <a:picLocks noChangeAspect="1"/>
+          </p:cNvPicPr>
+          <p:nvPr/>
+        </p:nvPicPr>
+        <p:blipFill>
+          <a:blip r:embed="rId3"/>
+          <a:stretch>
+            <a:fillRect/>
+          </a:stretch>
+        </p:blipFill>
+        <p:spPr>
+          <a:xfrm>
+            <a:off x="7343153" y="1874592"/>
+            <a:ext cx="2715004" cy="342948"/>
+          </a:xfrm>
+          <a:prstGeom prst="rect">
+            <a:avLst/>
+          </a:prstGeom>
+        </p:spPr>
+      </p:pic>
+      <p:pic>
+        <p:nvPicPr>
+          <p:cNvPr id="13" name="그림 12">
+            <a:extLst>
+              <a:ext uri="{FF2B5EF4-FFF2-40B4-BE49-F238E27FC236}">
+                <a16:creationId xmlns:a16="http://schemas.microsoft.com/office/drawing/2014/main" id="{DBE0C646-AD28-3EB0-3EC7-A384C4FB5621}"/>
+              </a:ext>
+            </a:extLst>
+          </p:cNvPr>
+          <p:cNvPicPr>
+            <a:picLocks noChangeAspect="1"/>
+          </p:cNvPicPr>
+          <p:nvPr/>
+        </p:nvPicPr>
+        <p:blipFill>
+          <a:blip r:embed="rId4"/>
+          <a:stretch>
+            <a:fillRect/>
+          </a:stretch>
+        </p:blipFill>
+        <p:spPr>
+          <a:xfrm>
+            <a:off x="7352679" y="2354772"/>
+            <a:ext cx="2327030" cy="376913"/>
+          </a:xfrm>
+          <a:prstGeom prst="rect">
+            <a:avLst/>
+          </a:prstGeom>
+        </p:spPr>
+      </p:pic>
+      <p:pic>
+        <p:nvPicPr>
+          <p:cNvPr id="15" name="그림 14">
+            <a:extLst>
+              <a:ext uri="{FF2B5EF4-FFF2-40B4-BE49-F238E27FC236}">
+                <a16:creationId xmlns:a16="http://schemas.microsoft.com/office/drawing/2014/main" id="{9869335D-8445-4A88-E406-BF749A7A095B}"/>
+              </a:ext>
+            </a:extLst>
+          </p:cNvPr>
+          <p:cNvPicPr>
+            <a:picLocks noChangeAspect="1"/>
+          </p:cNvPicPr>
+          <p:nvPr/>
+        </p:nvPicPr>
+        <p:blipFill>
+          <a:blip r:embed="rId5"/>
+          <a:stretch>
+            <a:fillRect/>
+          </a:stretch>
+        </p:blipFill>
+        <p:spPr>
+          <a:xfrm>
+            <a:off x="7343153" y="2909460"/>
+            <a:ext cx="2724530" cy="333422"/>
+          </a:xfrm>
+          <a:prstGeom prst="rect">
+            <a:avLst/>
+          </a:prstGeom>
+        </p:spPr>
+      </p:pic>
+      <p:pic>
+        <p:nvPicPr>
+          <p:cNvPr id="17" name="그림 16">
+            <a:extLst>
+              <a:ext uri="{FF2B5EF4-FFF2-40B4-BE49-F238E27FC236}">
+                <a16:creationId xmlns:a16="http://schemas.microsoft.com/office/drawing/2014/main" id="{6F7CCA1A-600D-49A9-7ECB-1E98287AFF09}"/>
+              </a:ext>
+            </a:extLst>
+          </p:cNvPr>
+          <p:cNvPicPr>
+            <a:picLocks noChangeAspect="1"/>
+          </p:cNvPicPr>
+          <p:nvPr/>
+        </p:nvPicPr>
+        <p:blipFill>
+          <a:blip r:embed="rId6"/>
+          <a:stretch>
+            <a:fillRect/>
+          </a:stretch>
+        </p:blipFill>
+        <p:spPr>
+          <a:xfrm>
+            <a:off x="7352679" y="3389640"/>
+            <a:ext cx="2810267" cy="333422"/>
+          </a:xfrm>
+          <a:prstGeom prst="rect">
+            <a:avLst/>
+          </a:prstGeom>
+        </p:spPr>
+      </p:pic>
+    </p:spTree>
+    <p:extLst>
+      <p:ext uri="{BB962C8B-B14F-4D97-AF65-F5344CB8AC3E}">
+        <p14:creationId xmlns:p14="http://schemas.microsoft.com/office/powerpoint/2010/main" val="3800402949"/>
+      </p:ext>
+    </p:extLst>
+  </p:cSld>
+  <p:clrMapOvr>
+    <a:masterClrMapping/>
+  </p:clrMapOvr>
+</p:sld>
+</file>
+
+<file path=ppt/slides/slide17.xml><?xml version="1.0" encoding="utf-8"?>
+<p:sld xmlns:a="http://schemas.openxmlformats.org/drawingml/2006/main" xmlns:r="http://schemas.openxmlformats.org/officeDocument/2006/relationships" xmlns:p="http://schemas.openxmlformats.org/presentationml/2006/main">
+  <p:cSld>
+    <p:spTree>
+      <p:nvGrpSpPr>
+        <p:cNvPr id="1" name=""/>
+        <p:cNvGrpSpPr/>
+        <p:nvPr/>
+      </p:nvGrpSpPr>
+      <p:grpSpPr>
+        <a:xfrm>
+          <a:off x="0" y="0"/>
+          <a:ext cx="0" cy="0"/>
+          <a:chOff x="0" y="0"/>
+          <a:chExt cx="0" cy="0"/>
+        </a:xfrm>
+      </p:grpSpPr>
+      <p:sp>
+        <p:nvSpPr>
+          <p:cNvPr id="2" name="제목 1">
+            <a:extLst>
+              <a:ext uri="{FF2B5EF4-FFF2-40B4-BE49-F238E27FC236}">
+                <a16:creationId xmlns:a16="http://schemas.microsoft.com/office/drawing/2014/main" id="{ED5D6949-EE0A-216D-B06D-BB4C526FEA3A}"/>
+              </a:ext>
+            </a:extLst>
+          </p:cNvPr>
+          <p:cNvSpPr>
+            <a:spLocks noGrp="1"/>
+          </p:cNvSpPr>
+          <p:nvPr>
+            <p:ph type="title"/>
+          </p:nvPr>
+        </p:nvSpPr>
+        <p:spPr/>
+        <p:txBody>
+          <a:bodyPr/>
+          <a:lstStyle/>
+          <a:p>
+            <a:r>
+              <a:rPr lang="ko-KR" altLang="en-US"/>
+              <a:t>캐시 적용</a:t>
+            </a:r>
+          </a:p>
+        </p:txBody>
+      </p:sp>
+      <p:pic>
+        <p:nvPicPr>
+          <p:cNvPr id="4" name="그림 3">
+            <a:extLst>
+              <a:ext uri="{FF2B5EF4-FFF2-40B4-BE49-F238E27FC236}">
+                <a16:creationId xmlns:a16="http://schemas.microsoft.com/office/drawing/2014/main" id="{7CE8418A-9ABA-B677-D4DC-9F63D6DFBD34}"/>
+              </a:ext>
+            </a:extLst>
+          </p:cNvPr>
+          <p:cNvPicPr>
+            <a:picLocks noChangeAspect="1"/>
+          </p:cNvPicPr>
+          <p:nvPr/>
+        </p:nvPicPr>
+        <p:blipFill>
+          <a:blip r:embed="rId2"/>
+          <a:stretch>
+            <a:fillRect/>
+          </a:stretch>
+        </p:blipFill>
+        <p:spPr>
+          <a:xfrm>
+            <a:off x="8307307" y="2052906"/>
+            <a:ext cx="2848373" cy="295316"/>
+          </a:xfrm>
+          <a:prstGeom prst="rect">
+            <a:avLst/>
+          </a:prstGeom>
+        </p:spPr>
+      </p:pic>
+      <p:pic>
+        <p:nvPicPr>
+          <p:cNvPr id="6" name="그림 5">
+            <a:extLst>
+              <a:ext uri="{FF2B5EF4-FFF2-40B4-BE49-F238E27FC236}">
+                <a16:creationId xmlns:a16="http://schemas.microsoft.com/office/drawing/2014/main" id="{2FB1FA44-943F-ECF5-DA39-1F28335EA348}"/>
+              </a:ext>
+            </a:extLst>
+          </p:cNvPr>
+          <p:cNvPicPr>
+            <a:picLocks noChangeAspect="1"/>
+          </p:cNvPicPr>
+          <p:nvPr/>
+        </p:nvPicPr>
+        <p:blipFill>
+          <a:blip r:embed="rId3"/>
+          <a:stretch>
+            <a:fillRect/>
+          </a:stretch>
+        </p:blipFill>
+        <p:spPr>
+          <a:xfrm>
+            <a:off x="418312" y="2052906"/>
+            <a:ext cx="7792816" cy="1423455"/>
+          </a:xfrm>
+          <a:prstGeom prst="rect">
+            <a:avLst/>
+          </a:prstGeom>
+        </p:spPr>
+      </p:pic>
+      <p:pic>
+        <p:nvPicPr>
+          <p:cNvPr id="8" name="그림 7">
+            <a:extLst>
+              <a:ext uri="{FF2B5EF4-FFF2-40B4-BE49-F238E27FC236}">
+                <a16:creationId xmlns:a16="http://schemas.microsoft.com/office/drawing/2014/main" id="{261137F0-6C7F-D6E4-25EA-7B40B68106E3}"/>
+              </a:ext>
+            </a:extLst>
+          </p:cNvPr>
+          <p:cNvPicPr>
+            <a:picLocks noChangeAspect="1"/>
+          </p:cNvPicPr>
+          <p:nvPr/>
+        </p:nvPicPr>
+        <p:blipFill>
+          <a:blip r:embed="rId4"/>
+          <a:stretch>
+            <a:fillRect/>
+          </a:stretch>
+        </p:blipFill>
+        <p:spPr>
+          <a:xfrm>
+            <a:off x="8307307" y="2492294"/>
+            <a:ext cx="2581635" cy="342948"/>
+          </a:xfrm>
+          <a:prstGeom prst="rect">
+            <a:avLst/>
+          </a:prstGeom>
+        </p:spPr>
+      </p:pic>
+      <p:pic>
+        <p:nvPicPr>
+          <p:cNvPr id="10" name="그림 9">
+            <a:extLst>
+              <a:ext uri="{FF2B5EF4-FFF2-40B4-BE49-F238E27FC236}">
+                <a16:creationId xmlns:a16="http://schemas.microsoft.com/office/drawing/2014/main" id="{358D8CBB-6B66-C8AA-7CE8-5632D92471EE}"/>
+              </a:ext>
+            </a:extLst>
+          </p:cNvPr>
+          <p:cNvPicPr>
+            <a:picLocks noChangeAspect="1"/>
+          </p:cNvPicPr>
+          <p:nvPr/>
+        </p:nvPicPr>
+        <p:blipFill>
+          <a:blip r:embed="rId5"/>
+          <a:stretch>
+            <a:fillRect/>
+          </a:stretch>
+        </p:blipFill>
+        <p:spPr>
+          <a:xfrm>
+            <a:off x="8307307" y="3000096"/>
+            <a:ext cx="2629267" cy="323895"/>
+          </a:xfrm>
+          <a:prstGeom prst="rect">
+            <a:avLst/>
+          </a:prstGeom>
+        </p:spPr>
+      </p:pic>
+      <p:pic>
+        <p:nvPicPr>
+          <p:cNvPr id="12" name="그림 11">
+            <a:extLst>
+              <a:ext uri="{FF2B5EF4-FFF2-40B4-BE49-F238E27FC236}">
+                <a16:creationId xmlns:a16="http://schemas.microsoft.com/office/drawing/2014/main" id="{10FF789B-AECD-B39C-9C21-1587771F9F94}"/>
+              </a:ext>
+            </a:extLst>
+          </p:cNvPr>
+          <p:cNvPicPr>
+            <a:picLocks noChangeAspect="1"/>
+          </p:cNvPicPr>
+          <p:nvPr/>
+        </p:nvPicPr>
+        <p:blipFill>
+          <a:blip r:embed="rId6"/>
+          <a:stretch>
+            <a:fillRect/>
+          </a:stretch>
+        </p:blipFill>
+        <p:spPr>
+          <a:xfrm>
+            <a:off x="8307307" y="3487116"/>
+            <a:ext cx="2638793" cy="438211"/>
+          </a:xfrm>
+          <a:prstGeom prst="rect">
+            <a:avLst/>
+          </a:prstGeom>
+        </p:spPr>
+      </p:pic>
+      <p:sp>
+        <p:nvSpPr>
+          <p:cNvPr id="13" name="TextBox 12">
+            <a:extLst>
+              <a:ext uri="{FF2B5EF4-FFF2-40B4-BE49-F238E27FC236}">
+                <a16:creationId xmlns:a16="http://schemas.microsoft.com/office/drawing/2014/main" id="{67C67C93-78FB-0A5C-CD6D-0D5E9E06B36F}"/>
+              </a:ext>
+            </a:extLst>
+          </p:cNvPr>
+          <p:cNvSpPr txBox="1"/>
+          <p:nvPr/>
+        </p:nvSpPr>
+        <p:spPr>
+          <a:xfrm>
+            <a:off x="418312" y="3706221"/>
+            <a:ext cx="7792816" cy="1384995"/>
+          </a:xfrm>
+          <a:prstGeom prst="rect">
+            <a:avLst/>
+          </a:prstGeom>
+          <a:noFill/>
+        </p:spPr>
+        <p:txBody>
+          <a:bodyPr wrap="square" rtlCol="0">
+            <a:spAutoFit/>
+          </a:bodyPr>
+          <a:lstStyle/>
+          <a:p>
+            <a:r>
+              <a:rPr lang="ko-KR" altLang="en-US" sz="1400"/>
+              <a:t>캐시를 적용하게 되면</a:t>
+            </a:r>
+            <a:r>
+              <a:rPr lang="en-US" altLang="ko-KR" sz="1400"/>
+              <a:t>, </a:t>
+            </a:r>
+            <a:r>
+              <a:rPr lang="ko-KR" altLang="en-US" sz="1400"/>
+              <a:t>첫 요청 시 캐시에 데이터가 존재하지 않음으로</a:t>
+            </a:r>
+            <a:r>
+              <a:rPr lang="en-US" altLang="ko-KR" sz="1400"/>
+              <a:t>.</a:t>
+            </a:r>
+            <a:br>
+              <a:rPr lang="en-US" altLang="ko-KR" sz="1400"/>
+            </a:br>
+            <a:r>
+              <a:rPr lang="en-US" altLang="ko-KR" sz="1400"/>
+              <a:t>Redis</a:t>
+            </a:r>
+            <a:r>
+              <a:rPr lang="ko-KR" altLang="en-US" sz="1400"/>
+              <a:t>에 조회 </a:t>
+            </a:r>
+            <a:r>
+              <a:rPr lang="en-US" altLang="ko-KR" sz="1400"/>
+              <a:t>Key</a:t>
+            </a:r>
+            <a:r>
+              <a:rPr lang="ko-KR" altLang="en-US" sz="1400"/>
+              <a:t> 확인 </a:t>
+            </a:r>
+            <a:r>
+              <a:rPr lang="en-US" altLang="ko-KR" sz="1400">
+                <a:sym typeface="Wingdings" panose="05000000000000000000" pitchFamily="2" charset="2"/>
+              </a:rPr>
+              <a:t> </a:t>
+            </a:r>
+            <a:r>
+              <a:rPr lang="ko-KR" altLang="en-US" sz="1400">
+                <a:sym typeface="Wingdings" panose="05000000000000000000" pitchFamily="2" charset="2"/>
+              </a:rPr>
+              <a:t>없음 </a:t>
+            </a:r>
+            <a:r>
+              <a:rPr lang="en-US" altLang="ko-KR" sz="1400">
+                <a:sym typeface="Wingdings" panose="05000000000000000000" pitchFamily="2" charset="2"/>
+              </a:rPr>
+              <a:t> DB </a:t>
+            </a:r>
+            <a:r>
+              <a:rPr lang="ko-KR" altLang="en-US" sz="1400">
+                <a:sym typeface="Wingdings" panose="05000000000000000000" pitchFamily="2" charset="2"/>
+              </a:rPr>
+              <a:t>조회 진행이 됨으로 </a:t>
+            </a:r>
+            <a:r>
+              <a:rPr lang="en-US" altLang="ko-KR" sz="1400">
+                <a:sym typeface="Wingdings" panose="05000000000000000000" pitchFamily="2" charset="2"/>
+              </a:rPr>
+              <a:t>DB</a:t>
+            </a:r>
+            <a:r>
+              <a:rPr lang="ko-KR" altLang="en-US" sz="1400">
+                <a:sym typeface="Wingdings" panose="05000000000000000000" pitchFamily="2" charset="2"/>
+              </a:rPr>
+              <a:t>조회보다 긴 시간</a:t>
+            </a:r>
+            <a:r>
+              <a:rPr lang="en-US" altLang="ko-KR" sz="1400">
+                <a:sym typeface="Wingdings" panose="05000000000000000000" pitchFamily="2" charset="2"/>
+              </a:rPr>
+              <a:t>(953ms)</a:t>
+            </a:r>
+            <a:r>
+              <a:rPr lang="ko-KR" altLang="en-US" sz="1400">
+                <a:sym typeface="Wingdings" panose="05000000000000000000" pitchFamily="2" charset="2"/>
+              </a:rPr>
+              <a:t>이 걸렸다</a:t>
+            </a:r>
+            <a:r>
+              <a:rPr lang="en-US" altLang="ko-KR" sz="1400">
+                <a:sym typeface="Wingdings" panose="05000000000000000000" pitchFamily="2" charset="2"/>
+              </a:rPr>
+              <a:t>.</a:t>
+            </a:r>
+          </a:p>
+          <a:p>
+            <a:r>
+              <a:rPr lang="ko-KR" altLang="en-US" sz="1400">
+                <a:sym typeface="Wingdings" panose="05000000000000000000" pitchFamily="2" charset="2"/>
+              </a:rPr>
+              <a:t>그러나 첫 조회 이후로는 </a:t>
+            </a:r>
+            <a:r>
+              <a:rPr lang="en-US" altLang="ko-KR" sz="1400">
+                <a:sym typeface="Wingdings" panose="05000000000000000000" pitchFamily="2" charset="2"/>
+              </a:rPr>
+              <a:t>Redis </a:t>
+            </a:r>
+            <a:r>
+              <a:rPr lang="ko-KR" altLang="en-US" sz="1400">
+                <a:sym typeface="Wingdings" panose="05000000000000000000" pitchFamily="2" charset="2"/>
+              </a:rPr>
+              <a:t>캐시에 저장됨으로 </a:t>
+            </a:r>
+            <a:r>
+              <a:rPr lang="en-US" altLang="ko-KR" sz="1400">
+                <a:sym typeface="Wingdings" panose="05000000000000000000" pitchFamily="2" charset="2"/>
+              </a:rPr>
+              <a:t>DB</a:t>
+            </a:r>
+            <a:r>
+              <a:rPr lang="ko-KR" altLang="en-US" sz="1400">
+                <a:sym typeface="Wingdings" panose="05000000000000000000" pitchFamily="2" charset="2"/>
+              </a:rPr>
+              <a:t>를 거치지 않고 </a:t>
+            </a:r>
+            <a:r>
+              <a:rPr lang="en-US" altLang="ko-KR" sz="1400">
+                <a:sym typeface="Wingdings" panose="05000000000000000000" pitchFamily="2" charset="2"/>
+              </a:rPr>
+              <a:t>Redis</a:t>
+            </a:r>
+            <a:r>
+              <a:rPr lang="ko-KR" altLang="en-US" sz="1400">
+                <a:sym typeface="Wingdings" panose="05000000000000000000" pitchFamily="2" charset="2"/>
+              </a:rPr>
+              <a:t>에 저장된 조회한 결과를 그대로 반환함으로 응답시간이 </a:t>
+            </a:r>
+            <a:r>
+              <a:rPr lang="en-US" altLang="ko-KR" sz="1400">
+                <a:sym typeface="Wingdings" panose="05000000000000000000" pitchFamily="2" charset="2"/>
+              </a:rPr>
+              <a:t>30ms </a:t>
+            </a:r>
+            <a:r>
+              <a:rPr lang="ko-KR" altLang="en-US" sz="1400">
+                <a:sym typeface="Wingdings" panose="05000000000000000000" pitchFamily="2" charset="2"/>
+              </a:rPr>
+              <a:t>이하가 나오는걸 볼 수 있다</a:t>
+            </a:r>
+            <a:r>
+              <a:rPr lang="en-US" altLang="ko-KR" sz="1400">
+                <a:sym typeface="Wingdings" panose="05000000000000000000" pitchFamily="2" charset="2"/>
+              </a:rPr>
+              <a:t>.</a:t>
+            </a:r>
+          </a:p>
+          <a:p>
+            <a:endParaRPr lang="en-US" altLang="ko-KR" sz="1400">
+              <a:sym typeface="Wingdings" panose="05000000000000000000" pitchFamily="2" charset="2"/>
+            </a:endParaRPr>
+          </a:p>
+          <a:p>
+            <a:endParaRPr lang="ko-KR" altLang="en-US" sz="1400"/>
+          </a:p>
+        </p:txBody>
+      </p:sp>
+    </p:spTree>
+    <p:extLst>
+      <p:ext uri="{BB962C8B-B14F-4D97-AF65-F5344CB8AC3E}">
+        <p14:creationId xmlns:p14="http://schemas.microsoft.com/office/powerpoint/2010/main" val="845135912"/>
+      </p:ext>
+    </p:extLst>
+  </p:cSld>
+  <p:clrMapOvr>
+    <a:masterClrMapping/>
+  </p:clrMapOvr>
+</p:sld>
+</file>
+
 <file path=ppt/slides/slide2.xml><?xml version="1.0" encoding="utf-8"?>
 <p:sld xmlns:a="http://schemas.openxmlformats.org/drawingml/2006/main" xmlns:r="http://schemas.openxmlformats.org/officeDocument/2006/relationships" xmlns:p="http://schemas.openxmlformats.org/presentationml/2006/main">
   <p:cSld>
@@ -4549,36 +7798,6 @@
           </a:p>
         </p:txBody>
       </p:sp>
-      <p:pic>
-        <p:nvPicPr>
-          <p:cNvPr id="6" name="그림 5">
-            <a:extLst>
-              <a:ext uri="{FF2B5EF4-FFF2-40B4-BE49-F238E27FC236}">
-                <a16:creationId xmlns:a16="http://schemas.microsoft.com/office/drawing/2014/main" id="{9FC75CA8-6AAE-258B-FE77-470B712D9255}"/>
-              </a:ext>
-            </a:extLst>
-          </p:cNvPr>
-          <p:cNvPicPr>
-            <a:picLocks noChangeAspect="1"/>
-          </p:cNvPicPr>
-          <p:nvPr/>
-        </p:nvPicPr>
-        <p:blipFill>
-          <a:blip r:embed="rId2"/>
-          <a:stretch>
-            <a:fillRect/>
-          </a:stretch>
-        </p:blipFill>
-        <p:spPr>
-          <a:xfrm>
-            <a:off x="3520579" y="1802012"/>
-            <a:ext cx="3805252" cy="4543370"/>
-          </a:xfrm>
-          <a:prstGeom prst="rect">
-            <a:avLst/>
-          </a:prstGeom>
-        </p:spPr>
-      </p:pic>
       <p:grpSp>
         <p:nvGrpSpPr>
           <p:cNvPr id="8" name="그룹 7">
@@ -4614,7 +7833,7 @@
             <p:nvPr/>
           </p:nvPicPr>
           <p:blipFill>
-            <a:blip r:embed="rId3"/>
+            <a:blip r:embed="rId2"/>
             <a:stretch>
               <a:fillRect/>
             </a:stretch>
@@ -4682,6 +7901,36 @@
           </p:txBody>
         </p:sp>
       </p:grpSp>
+      <p:pic>
+        <p:nvPicPr>
+          <p:cNvPr id="10" name="그림 9">
+            <a:extLst>
+              <a:ext uri="{FF2B5EF4-FFF2-40B4-BE49-F238E27FC236}">
+                <a16:creationId xmlns:a16="http://schemas.microsoft.com/office/drawing/2014/main" id="{2AAB2297-EAFB-272D-1D8C-13367CD0E1CA}"/>
+              </a:ext>
+            </a:extLst>
+          </p:cNvPr>
+          <p:cNvPicPr>
+            <a:picLocks noChangeAspect="1"/>
+          </p:cNvPicPr>
+          <p:nvPr/>
+        </p:nvPicPr>
+        <p:blipFill>
+          <a:blip r:embed="rId3"/>
+          <a:stretch>
+            <a:fillRect/>
+          </a:stretch>
+        </p:blipFill>
+        <p:spPr>
+          <a:xfrm>
+            <a:off x="3561996" y="1802012"/>
+            <a:ext cx="4224259" cy="5026233"/>
+          </a:xfrm>
+          <a:prstGeom prst="rect">
+            <a:avLst/>
+          </a:prstGeom>
+        </p:spPr>
+      </p:pic>
     </p:spTree>
     <p:extLst>
       <p:ext uri="{BB962C8B-B14F-4D97-AF65-F5344CB8AC3E}">

</xml_diff>